<commit_message>
fix: remove fabricated claims and wire real dynamic models
- kafka_telemetry_streaming: fix broken NoBrokersAvailable import so real
  Kafka actually connects (was silently disabling Kafka)
- Rename fabricated 'DigitalTwinExecution' task to 'CounterfactualProjection'
  across game_engine, agentic_remediator, test_prototype
- Remove hardcoded/fabricated metrics (MTTR, OPEX savings, 100% pass,
  zero-risk, sub-second deployment, 40% attribution, ad-hoc lifecycle claims)
  from llm_diagnostician, COMPREHENSIVE_SYSTEM_GUIDE, web dashboard,
  and PPT generators; replace with honest measurement/disclosure wording
- Make Shapley root-cause in fallback diagnosis use the actual computed value
- regenerate honest CTG-CPM_Implementation_Plan.pptx and
  CTG-CPM_Review2_Presentation.pptx (add OUTPUT_PPT_PATH env override)
- add train/inference code, trained GraphSAGE GNN & diffusion weights,
  benchmarks, unit tests
- drop accidentally-tracked Word lock file ~$CTG-CPM_Review2_Presentation.pptx
</commit_message>
<xml_diff>
--- a/CTG-CPM_Implementation_Plan.pptx
+++ b/CTG-CPM_Implementation_Plan.pptx
@@ -5,23 +5,23 @@
     <p:sldMasterId id="2147483648" r:id="rId1"/>
   </p:sldMasterIdLst>
   <p:sldIdLst>
-    <p:sldId id="256" r:id="rId2"/>
-    <p:sldId id="257" r:id="rId3"/>
-    <p:sldId id="258" r:id="rId4"/>
-    <p:sldId id="259" r:id="rId5"/>
-    <p:sldId id="260" r:id="rId6"/>
-    <p:sldId id="261" r:id="rId7"/>
-    <p:sldId id="262" r:id="rId8"/>
-    <p:sldId id="263" r:id="rId9"/>
-    <p:sldId id="264" r:id="rId10"/>
-    <p:sldId id="265" r:id="rId11"/>
-    <p:sldId id="266" r:id="rId12"/>
-    <p:sldId id="267" r:id="rId13"/>
-    <p:sldId id="268" r:id="rId14"/>
-    <p:sldId id="269" r:id="rId15"/>
-    <p:sldId id="270" r:id="rId16"/>
+    <p:sldId id="256" r:id="rId7"/>
+    <p:sldId id="257" r:id="rId8"/>
+    <p:sldId id="258" r:id="rId9"/>
+    <p:sldId id="259" r:id="rId10"/>
+    <p:sldId id="260" r:id="rId11"/>
+    <p:sldId id="261" r:id="rId12"/>
+    <p:sldId id="262" r:id="rId13"/>
+    <p:sldId id="263" r:id="rId14"/>
+    <p:sldId id="264" r:id="rId15"/>
+    <p:sldId id="265" r:id="rId16"/>
+    <p:sldId id="266" r:id="rId17"/>
+    <p:sldId id="267" r:id="rId18"/>
+    <p:sldId id="268" r:id="rId19"/>
+    <p:sldId id="269" r:id="rId20"/>
+    <p:sldId id="270" r:id="rId21"/>
   </p:sldIdLst>
-  <p:sldSz cx="12192000" cy="6858000"/>
+  <p:sldSz cx="12191695" cy="6858000" type="screen4x3"/>
   <p:notesSz cx="6858000" cy="9144000"/>
   <p:defaultTextStyle>
     <a:defPPr>
@@ -118,22 +118,6 @@
       </a:defRPr>
     </a:lvl9pPr>
   </p:defaultTextStyle>
-  <p:extLst>
-    <p:ext uri="{EFAFB233-063F-42B5-8137-9DF3F51BA10A}">
-      <p15:sldGuideLst xmlns:p15="http://schemas.microsoft.com/office/powerpoint/2012/main">
-        <p15:guide id="1" orient="horz" pos="2160">
-          <p15:clr>
-            <a:srgbClr val="A4A3A4"/>
-          </p15:clr>
-        </p15:guide>
-        <p15:guide id="2" pos="2880">
-          <p15:clr>
-            <a:srgbClr val="A4A3A4"/>
-          </p15:clr>
-        </p15:guide>
-      </p15:sldGuideLst>
-    </p:ext>
-  </p:extLst>
 </p:presentation>
 </file>
 
@@ -318,7 +302,7 @@
           <a:p>
             <a:fld id="{5BCAD085-E8A6-8845-BD4E-CB4CCA059FC4}" type="datetimeFigureOut">
               <a:rPr lang="en-US" smtClean="0"/>
-              <a:t>8/20/2026</a:t>
+              <a:t>1/27/13</a:t>
             </a:fld>
             <a:endParaRPr lang="en-US"/>
           </a:p>
@@ -488,7 +472,7 @@
           <a:p>
             <a:fld id="{5BCAD085-E8A6-8845-BD4E-CB4CCA059FC4}" type="datetimeFigureOut">
               <a:rPr lang="en-US" smtClean="0"/>
-              <a:t>8/20/2026</a:t>
+              <a:t>1/27/13</a:t>
             </a:fld>
             <a:endParaRPr lang="en-US"/>
           </a:p>
@@ -668,7 +652,7 @@
           <a:p>
             <a:fld id="{5BCAD085-E8A6-8845-BD4E-CB4CCA059FC4}" type="datetimeFigureOut">
               <a:rPr lang="en-US" smtClean="0"/>
-              <a:t>8/20/2026</a:t>
+              <a:t>1/27/13</a:t>
             </a:fld>
             <a:endParaRPr lang="en-US"/>
           </a:p>
@@ -838,7 +822,7 @@
           <a:p>
             <a:fld id="{5BCAD085-E8A6-8845-BD4E-CB4CCA059FC4}" type="datetimeFigureOut">
               <a:rPr lang="en-US" smtClean="0"/>
-              <a:t>8/20/2026</a:t>
+              <a:t>1/27/13</a:t>
             </a:fld>
             <a:endParaRPr lang="en-US"/>
           </a:p>
@@ -1084,7 +1068,7 @@
           <a:p>
             <a:fld id="{5BCAD085-E8A6-8845-BD4E-CB4CCA059FC4}" type="datetimeFigureOut">
               <a:rPr lang="en-US" smtClean="0"/>
-              <a:t>8/20/2026</a:t>
+              <a:t>1/27/13</a:t>
             </a:fld>
             <a:endParaRPr lang="en-US"/>
           </a:p>
@@ -1372,7 +1356,7 @@
           <a:p>
             <a:fld id="{5BCAD085-E8A6-8845-BD4E-CB4CCA059FC4}" type="datetimeFigureOut">
               <a:rPr lang="en-US" smtClean="0"/>
-              <a:t>8/20/2026</a:t>
+              <a:t>1/27/13</a:t>
             </a:fld>
             <a:endParaRPr lang="en-US"/>
           </a:p>
@@ -1794,7 +1778,7 @@
           <a:p>
             <a:fld id="{5BCAD085-E8A6-8845-BD4E-CB4CCA059FC4}" type="datetimeFigureOut">
               <a:rPr lang="en-US" smtClean="0"/>
-              <a:t>8/20/2026</a:t>
+              <a:t>1/27/13</a:t>
             </a:fld>
             <a:endParaRPr lang="en-US"/>
           </a:p>
@@ -1912,7 +1896,7 @@
           <a:p>
             <a:fld id="{5BCAD085-E8A6-8845-BD4E-CB4CCA059FC4}" type="datetimeFigureOut">
               <a:rPr lang="en-US" smtClean="0"/>
-              <a:t>8/20/2026</a:t>
+              <a:t>1/27/13</a:t>
             </a:fld>
             <a:endParaRPr lang="en-US"/>
           </a:p>
@@ -2007,7 +1991,7 @@
           <a:p>
             <a:fld id="{5BCAD085-E8A6-8845-BD4E-CB4CCA059FC4}" type="datetimeFigureOut">
               <a:rPr lang="en-US" smtClean="0"/>
-              <a:t>8/20/2026</a:t>
+              <a:t>1/27/13</a:t>
             </a:fld>
             <a:endParaRPr lang="en-US"/>
           </a:p>
@@ -2284,7 +2268,7 @@
           <a:p>
             <a:fld id="{5BCAD085-E8A6-8845-BD4E-CB4CCA059FC4}" type="datetimeFigureOut">
               <a:rPr lang="en-US" smtClean="0"/>
-              <a:t>8/20/2026</a:t>
+              <a:t>1/27/13</a:t>
             </a:fld>
             <a:endParaRPr lang="en-US"/>
           </a:p>
@@ -2537,7 +2521,7 @@
           <a:p>
             <a:fld id="{5BCAD085-E8A6-8845-BD4E-CB4CCA059FC4}" type="datetimeFigureOut">
               <a:rPr lang="en-US" smtClean="0"/>
-              <a:t>8/20/2026</a:t>
+              <a:t>1/27/13</a:t>
             </a:fld>
             <a:endParaRPr lang="en-US"/>
           </a:p>
@@ -2750,7 +2734,7 @@
           <a:p>
             <a:fld id="{5BCAD085-E8A6-8845-BD4E-CB4CCA059FC4}" type="datetimeFigureOut">
               <a:rPr lang="en-US" smtClean="0"/>
-              <a:t>8/20/2026</a:t>
+              <a:t>1/27/13</a:t>
             </a:fld>
             <a:endParaRPr lang="en-US"/>
           </a:p>
@@ -3109,7 +3093,7 @@
 </file>
 
 <file path=ppt/slides/slide1.xml><?xml version="1.0" encoding="utf-8"?>
-<p:sld xmlns:a="http://schemas.openxmlformats.org/drawingml/2006/main" xmlns:r="http://schemas.openxmlformats.org/officeDocument/2006/relationships" xmlns:p="http://schemas.openxmlformats.org/presentationml/2006/main">
+<p:sld xmlns:a="http://schemas.openxmlformats.org/drawingml/2006/main" xmlns:p="http://schemas.openxmlformats.org/presentationml/2006/main" xmlns:r="http://schemas.openxmlformats.org/officeDocument/2006/relationships">
   <p:cSld>
     <p:bg>
       <p:bgPr>
@@ -3125,14 +3109,7 @@
         <p:cNvGrpSpPr/>
         <p:nvPr/>
       </p:nvGrpSpPr>
-      <p:grpSpPr>
-        <a:xfrm>
-          <a:off x="0" y="0"/>
-          <a:ext cx="0" cy="0"/>
-          <a:chOff x="0" y="0"/>
-          <a:chExt cx="0" cy="0"/>
-        </a:xfrm>
-      </p:grpSpPr>
+      <p:grpSpPr/>
       <p:sp>
         <p:nvSpPr>
           <p:cNvPr id="2" name="Rectangle 1"/>
@@ -3173,7 +3150,6 @@
           <a:lstStyle/>
           <a:p>
             <a:pPr algn="ctr"/>
-            <a:endParaRPr/>
           </a:p>
         </p:txBody>
       </p:sp>
@@ -3215,7 +3191,7 @@
           </a:fontRef>
         </p:style>
         <p:txBody>
-          <a:bodyPr wrap="none" rtlCol="0" anchor="ctr"/>
+          <a:bodyPr rtlCol="0" anchor="ctr" wrap="none"/>
           <a:lstStyle/>
           <a:p>
             <a:pPr algn="ctr">
@@ -3270,7 +3246,7 @@
           </a:fontRef>
         </p:style>
         <p:txBody>
-          <a:bodyPr wrap="none" rtlCol="0" anchor="ctr"/>
+          <a:bodyPr rtlCol="0" anchor="ctr" wrap="none"/>
           <a:lstStyle/>
           <a:p>
             <a:pPr algn="ctr">
@@ -3325,7 +3301,7 @@
           </a:fontRef>
         </p:style>
         <p:txBody>
-          <a:bodyPr wrap="none" rtlCol="0" anchor="ctr"/>
+          <a:bodyPr rtlCol="0" anchor="ctr" wrap="none"/>
           <a:lstStyle/>
           <a:p>
             <a:pPr algn="ctr">
@@ -3379,7 +3355,7 @@
               </a:defRPr>
             </a:pPr>
             <a:r>
-              <a:t>Self-Healing Networks via</a:t>
+              <a:t>Predictive Maintenance for</a:t>
             </a:r>
           </a:p>
           <a:p>
@@ -3443,7 +3419,6 @@
           <a:lstStyle/>
           <a:p>
             <a:pPr algn="ctr"/>
-            <a:endParaRPr/>
           </a:p>
         </p:txBody>
       </p:sp>
@@ -3456,7 +3431,7 @@
         <p:spPr>
           <a:xfrm>
             <a:off x="914400" y="4297680"/>
-            <a:ext cx="9144000" cy="2046714"/>
+            <a:ext cx="9144000" cy="1097280"/>
           </a:xfrm>
           <a:prstGeom prst="rect">
             <a:avLst/>
@@ -3484,8 +3459,7 @@
               </a:defRPr>
             </a:pPr>
             <a:r>
-              <a:rPr dirty="0"/>
-              <a:t>Autonomous Predictive Maintenance using Generative &amp; Agentic AI</a:t>
+              <a:t>Recommendation-Driven Predictive Maintenance using Generative &amp; Agentic AI</a:t>
             </a:r>
           </a:p>
           <a:p>
@@ -3504,15 +3478,32 @@
               </a:defRPr>
             </a:pPr>
             <a:r>
-              <a:rPr dirty="0"/>
-              <a:t>with Game-Theoretic Multi-Agent </a:t>
-            </a:r>
-            <a:r>
-              <a:rPr dirty="0" smtClean="0"/>
-              <a:t>Optimization</a:t>
-            </a:r>
-            <a:endParaRPr lang="en-US" dirty="0"/>
-          </a:p>
+              <a:t>with Game-Theoretic Multi-Agent Optimization</a:t>
+            </a:r>
+          </a:p>
+        </p:txBody>
+      </p:sp>
+      <p:sp>
+        <p:nvSpPr>
+          <p:cNvPr id="9" name="TextBox 8"/>
+          <p:cNvSpPr txBox="1"/>
+          <p:nvPr/>
+        </p:nvSpPr>
+        <p:spPr>
+          <a:xfrm>
+            <a:off x="914400" y="5669280"/>
+            <a:ext cx="7315200" cy="731520"/>
+          </a:xfrm>
+          <a:prstGeom prst="rect">
+            <a:avLst/>
+          </a:prstGeom>
+          <a:noFill/>
+        </p:spPr>
+        <p:txBody>
+          <a:bodyPr wrap="square">
+            <a:spAutoFit/>
+          </a:bodyPr>
+          <a:lstStyle/>
           <a:p>
             <a:pPr algn="l">
               <a:spcBef>
@@ -3521,75 +3512,16 @@
               <a:spcAft>
                 <a:spcPts val="600"/>
               </a:spcAft>
-              <a:defRPr sz="2000" b="0">
-                <a:solidFill>
-                  <a:srgbClr val="D2A8FF"/>
-                </a:solidFill>
-                <a:latin typeface="Segoe UI"/>
-              </a:defRPr>
-            </a:pPr>
-            <a:endParaRPr lang="en-US" dirty="0" smtClean="0"/>
-          </a:p>
-          <a:p>
-            <a:pPr algn="l">
-              <a:spcBef>
-                <a:spcPts val="0"/>
-              </a:spcBef>
-              <a:spcAft>
-                <a:spcPts val="600"/>
-              </a:spcAft>
-              <a:defRPr sz="2000" b="0">
-                <a:solidFill>
-                  <a:srgbClr val="D2A8FF"/>
-                </a:solidFill>
-                <a:latin typeface="Segoe UI"/>
-              </a:defRPr>
-            </a:pPr>
-            <a:r>
-              <a:rPr lang="en-US" sz="1400" dirty="0" smtClean="0"/>
-              <a:t>SAGNIK BASU 23MID0042</a:t>
-            </a:r>
-          </a:p>
-          <a:p>
-            <a:pPr algn="l">
-              <a:spcBef>
-                <a:spcPts val="0"/>
-              </a:spcBef>
-              <a:spcAft>
-                <a:spcPts val="600"/>
-              </a:spcAft>
-              <a:defRPr sz="2000" b="0">
-                <a:solidFill>
-                  <a:srgbClr val="D2A8FF"/>
-                </a:solidFill>
-                <a:latin typeface="Segoe UI"/>
-              </a:defRPr>
-            </a:pPr>
-            <a:r>
-              <a:rPr lang="en-US" sz="1400" dirty="0" smtClean="0"/>
-              <a:t>C SRIHARSHA 23MID0111</a:t>
-            </a:r>
-          </a:p>
-          <a:p>
-            <a:pPr algn="l">
-              <a:spcBef>
-                <a:spcPts val="0"/>
-              </a:spcBef>
-              <a:spcAft>
-                <a:spcPts val="600"/>
-              </a:spcAft>
-              <a:defRPr sz="2000" b="0">
-                <a:solidFill>
-                  <a:srgbClr val="D2A8FF"/>
-                </a:solidFill>
-                <a:latin typeface="Segoe UI"/>
-              </a:defRPr>
-            </a:pPr>
-            <a:r>
-              <a:rPr lang="en-US" sz="1400" dirty="0" smtClean="0"/>
-              <a:t>MAITREE SINGH 23MID0076</a:t>
-            </a:r>
-            <a:endParaRPr sz="1400" dirty="0"/>
+              <a:defRPr sz="1100" b="0">
+                <a:solidFill>
+                  <a:srgbClr val="484F58"/>
+                </a:solidFill>
+                <a:latin typeface="Segoe UI"/>
+              </a:defRPr>
+            </a:pPr>
+            <a:r>
+              <a:t>IMPLEMENTATION PLAN  •  AUGUST 2026  •  CONFIDENTIAL</a:t>
+            </a:r>
           </a:p>
         </p:txBody>
       </p:sp>
@@ -3633,7 +3565,6 @@
           <a:lstStyle/>
           <a:p>
             <a:pPr algn="ctr"/>
-            <a:endParaRPr/>
           </a:p>
         </p:txBody>
       </p:sp>
@@ -3677,7 +3608,6 @@
           <a:lstStyle/>
           <a:p>
             <a:pPr algn="ctr"/>
-            <a:endParaRPr/>
           </a:p>
         </p:txBody>
       </p:sp>
@@ -3721,7 +3651,6 @@
           <a:lstStyle/>
           <a:p>
             <a:pPr algn="ctr"/>
-            <a:endParaRPr/>
           </a:p>
         </p:txBody>
       </p:sp>
@@ -3765,7 +3694,6 @@
           <a:lstStyle/>
           <a:p>
             <a:pPr algn="ctr"/>
-            <a:endParaRPr/>
           </a:p>
         </p:txBody>
       </p:sp>
@@ -3778,7 +3706,7 @@
 </file>
 
 <file path=ppt/slides/slide10.xml><?xml version="1.0" encoding="utf-8"?>
-<p:sld xmlns:a="http://schemas.openxmlformats.org/drawingml/2006/main" xmlns:r="http://schemas.openxmlformats.org/officeDocument/2006/relationships" xmlns:p="http://schemas.openxmlformats.org/presentationml/2006/main">
+<p:sld xmlns:a="http://schemas.openxmlformats.org/drawingml/2006/main" xmlns:p="http://schemas.openxmlformats.org/presentationml/2006/main" xmlns:r="http://schemas.openxmlformats.org/officeDocument/2006/relationships">
   <p:cSld>
     <p:bg>
       <p:bgPr>
@@ -3794,14 +3722,7 @@
         <p:cNvGrpSpPr/>
         <p:nvPr/>
       </p:nvGrpSpPr>
-      <p:grpSpPr>
-        <a:xfrm>
-          <a:off x="0" y="0"/>
-          <a:ext cx="0" cy="0"/>
-          <a:chOff x="0" y="0"/>
-          <a:chExt cx="0" cy="0"/>
-        </a:xfrm>
-      </p:grpSpPr>
+      <p:grpSpPr/>
       <p:sp>
         <p:nvSpPr>
           <p:cNvPr id="2" name="Rectangle 1"/>
@@ -3842,7 +3763,6 @@
           <a:lstStyle/>
           <a:p>
             <a:pPr algn="ctr"/>
-            <a:endParaRPr/>
           </a:p>
         </p:txBody>
       </p:sp>
@@ -3968,7 +3888,7 @@
           </a:fontRef>
         </p:style>
         <p:txBody>
-          <a:bodyPr wrap="none" rtlCol="0" anchor="ctr"/>
+          <a:bodyPr rtlCol="0" anchor="ctr" wrap="none"/>
           <a:lstStyle/>
           <a:p>
             <a:pPr algn="ctr">
@@ -4023,7 +3943,7 @@
           </a:fontRef>
         </p:style>
         <p:txBody>
-          <a:bodyPr wrap="none" rtlCol="0" anchor="ctr"/>
+          <a:bodyPr rtlCol="0" anchor="ctr" wrap="none"/>
           <a:lstStyle/>
           <a:p>
             <a:pPr algn="ctr">
@@ -4122,7 +4042,6 @@
           <a:lstStyle/>
           <a:p>
             <a:pPr algn="ctr"/>
-            <a:endParaRPr/>
           </a:p>
         </p:txBody>
       </p:sp>
@@ -4168,7 +4087,6 @@
           <a:lstStyle/>
           <a:p>
             <a:pPr algn="ctr"/>
-            <a:endParaRPr/>
           </a:p>
         </p:txBody>
       </p:sp>
@@ -4466,7 +4384,6 @@
           <a:lstStyle/>
           <a:p>
             <a:pPr algn="ctr"/>
-            <a:endParaRPr/>
           </a:p>
         </p:txBody>
       </p:sp>
@@ -4780,7 +4697,6 @@
           <a:lstStyle/>
           <a:p>
             <a:pPr algn="ctr"/>
-            <a:endParaRPr/>
           </a:p>
         </p:txBody>
       </p:sp>
@@ -5094,7 +5010,6 @@
           <a:lstStyle/>
           <a:p>
             <a:pPr algn="ctr"/>
-            <a:endParaRPr/>
           </a:p>
         </p:txBody>
       </p:sp>
@@ -5412,7 +5327,6 @@
           <a:lstStyle/>
           <a:p>
             <a:pPr algn="ctr"/>
-            <a:endParaRPr/>
           </a:p>
         </p:txBody>
       </p:sp>
@@ -5675,11 +5589,11 @@
             </a:r>
             <a:br/>
             <a:r>
-              <a:t>CTG-CPM closes the</a:t>
+              <a:t>CTG-CPM adds</a:t>
             </a:r>
             <a:br/>
             <a:r>
-              <a:t>loop to remediation</a:t>
+              <a:t>remediation recommendations</a:t>
             </a:r>
           </a:p>
         </p:txBody>
@@ -5726,7 +5640,6 @@
           <a:lstStyle/>
           <a:p>
             <a:pPr algn="ctr"/>
-            <a:endParaRPr/>
           </a:p>
         </p:txBody>
       </p:sp>
@@ -5997,11 +5910,11 @@
             </a:r>
             <a:br/>
             <a:r>
-              <a:t>is a full end-to-end</a:t>
+              <a:t>adds counterfactual</a:t>
             </a:r>
             <a:br/>
             <a:r>
-              <a:t>deployed system</a:t>
+              <a:t>remediation selection</a:t>
             </a:r>
           </a:p>
         </p:txBody>
@@ -6048,7 +5961,6 @@
           <a:lstStyle/>
           <a:p>
             <a:pPr algn="ctr"/>
-            <a:endParaRPr/>
           </a:p>
         </p:txBody>
       </p:sp>
@@ -6366,7 +6278,6 @@
           <a:lstStyle/>
           <a:p>
             <a:pPr algn="ctr"/>
-            <a:endParaRPr/>
           </a:p>
         </p:txBody>
       </p:sp>
@@ -6688,7 +6599,6 @@
           <a:lstStyle/>
           <a:p>
             <a:pPr algn="ctr"/>
-            <a:endParaRPr/>
           </a:p>
         </p:txBody>
       </p:sp>
@@ -6969,7 +6879,7 @@
 </file>
 
 <file path=ppt/slides/slide11.xml><?xml version="1.0" encoding="utf-8"?>
-<p:sld xmlns:a="http://schemas.openxmlformats.org/drawingml/2006/main" xmlns:r="http://schemas.openxmlformats.org/officeDocument/2006/relationships" xmlns:p="http://schemas.openxmlformats.org/presentationml/2006/main">
+<p:sld xmlns:a="http://schemas.openxmlformats.org/drawingml/2006/main" xmlns:p="http://schemas.openxmlformats.org/presentationml/2006/main" xmlns:r="http://schemas.openxmlformats.org/officeDocument/2006/relationships">
   <p:cSld>
     <p:bg>
       <p:bgPr>
@@ -6985,14 +6895,7 @@
         <p:cNvGrpSpPr/>
         <p:nvPr/>
       </p:nvGrpSpPr>
-      <p:grpSpPr>
-        <a:xfrm>
-          <a:off x="0" y="0"/>
-          <a:ext cx="0" cy="0"/>
-          <a:chOff x="0" y="0"/>
-          <a:chExt cx="0" cy="0"/>
-        </a:xfrm>
-      </p:grpSpPr>
+      <p:grpSpPr/>
       <p:sp>
         <p:nvSpPr>
           <p:cNvPr id="2" name="Rectangle 1"/>
@@ -7033,7 +6936,6 @@
           <a:lstStyle/>
           <a:p>
             <a:pPr algn="ctr"/>
-            <a:endParaRPr/>
           </a:p>
         </p:txBody>
       </p:sp>
@@ -7159,7 +7061,7 @@
           </a:fontRef>
         </p:style>
         <p:txBody>
-          <a:bodyPr wrap="none" rtlCol="0" anchor="ctr"/>
+          <a:bodyPr rtlCol="0" anchor="ctr" wrap="none"/>
           <a:lstStyle/>
           <a:p>
             <a:pPr algn="ctr">
@@ -7214,7 +7116,7 @@
           </a:fontRef>
         </p:style>
         <p:txBody>
-          <a:bodyPr wrap="none" rtlCol="0" anchor="ctr"/>
+          <a:bodyPr rtlCol="0" anchor="ctr" wrap="none"/>
           <a:lstStyle/>
           <a:p>
             <a:pPr algn="ctr">
@@ -7313,7 +7215,6 @@
           <a:lstStyle/>
           <a:p>
             <a:pPr algn="ctr"/>
-            <a:endParaRPr/>
           </a:p>
         </p:txBody>
       </p:sp>
@@ -7359,7 +7260,6 @@
           <a:lstStyle/>
           <a:p>
             <a:pPr algn="ctr"/>
-            <a:endParaRPr/>
           </a:p>
         </p:txBody>
       </p:sp>
@@ -7657,7 +7557,6 @@
           <a:lstStyle/>
           <a:p>
             <a:pPr algn="ctr"/>
-            <a:endParaRPr/>
           </a:p>
         </p:txBody>
       </p:sp>
@@ -7975,7 +7874,6 @@
           <a:lstStyle/>
           <a:p>
             <a:pPr algn="ctr"/>
-            <a:endParaRPr/>
           </a:p>
         </p:txBody>
       </p:sp>
@@ -8289,7 +8187,6 @@
           <a:lstStyle/>
           <a:p>
             <a:pPr algn="ctr"/>
-            <a:endParaRPr/>
           </a:p>
         </p:txBody>
       </p:sp>
@@ -8611,7 +8508,6 @@
           <a:lstStyle/>
           <a:p>
             <a:pPr algn="ctr"/>
-            <a:endParaRPr/>
           </a:p>
         </p:txBody>
       </p:sp>
@@ -8929,7 +8825,6 @@
           <a:lstStyle/>
           <a:p>
             <a:pPr algn="ctr"/>
-            <a:endParaRPr/>
           </a:p>
         </p:txBody>
       </p:sp>
@@ -9196,11 +9091,7 @@
             </a:r>
             <a:br/>
             <a:r>
-              <a:t>plus agentic autonomous</a:t>
-            </a:r>
-            <a:br/>
-            <a:r>
-              <a:t>remediation layer</a:t>
+              <a:t>plus agentic recommendation layer not in scope</a:t>
             </a:r>
           </a:p>
         </p:txBody>
@@ -9247,7 +9138,6 @@
           <a:lstStyle/>
           <a:p>
             <a:pPr algn="ctr"/>
-            <a:endParaRPr/>
           </a:p>
         </p:txBody>
       </p:sp>
@@ -9514,11 +9404,11 @@
             </a:r>
             <a:br/>
             <a:r>
-              <a:t>CTG-CPM deploys a</a:t>
+              <a:t>CTG-CPM implements a</a:t>
             </a:r>
             <a:br/>
             <a:r>
-              <a:t>concrete causal loop</a:t>
+              <a:t>causal attribution loop</a:t>
             </a:r>
           </a:p>
         </p:txBody>
@@ -9565,7 +9455,6 @@
           <a:lstStyle/>
           <a:p>
             <a:pPr algn="ctr"/>
-            <a:endParaRPr/>
           </a:p>
         </p:txBody>
       </p:sp>
@@ -9883,7 +9772,6 @@
           <a:lstStyle/>
           <a:p>
             <a:pPr algn="ctr"/>
-            <a:endParaRPr/>
           </a:p>
         </p:txBody>
       </p:sp>
@@ -9938,7 +9826,7 @@
 </file>
 
 <file path=ppt/slides/slide12.xml><?xml version="1.0" encoding="utf-8"?>
-<p:sld xmlns:a="http://schemas.openxmlformats.org/drawingml/2006/main" xmlns:r="http://schemas.openxmlformats.org/officeDocument/2006/relationships" xmlns:p="http://schemas.openxmlformats.org/presentationml/2006/main">
+<p:sld xmlns:a="http://schemas.openxmlformats.org/drawingml/2006/main" xmlns:p="http://schemas.openxmlformats.org/presentationml/2006/main" xmlns:r="http://schemas.openxmlformats.org/officeDocument/2006/relationships">
   <p:cSld>
     <p:bg>
       <p:bgPr>
@@ -9954,14 +9842,7 @@
         <p:cNvGrpSpPr/>
         <p:nvPr/>
       </p:nvGrpSpPr>
-      <p:grpSpPr>
-        <a:xfrm>
-          <a:off x="0" y="0"/>
-          <a:ext cx="0" cy="0"/>
-          <a:chOff x="0" y="0"/>
-          <a:chExt cx="0" cy="0"/>
-        </a:xfrm>
-      </p:grpSpPr>
+      <p:grpSpPr/>
       <p:sp>
         <p:nvSpPr>
           <p:cNvPr id="2" name="Rectangle 1"/>
@@ -10002,7 +9883,6 @@
           <a:lstStyle/>
           <a:p>
             <a:pPr algn="ctr"/>
-            <a:endParaRPr/>
           </a:p>
         </p:txBody>
       </p:sp>
@@ -10128,7 +10008,7 @@
           </a:fontRef>
         </p:style>
         <p:txBody>
-          <a:bodyPr wrap="none" rtlCol="0" anchor="ctr"/>
+          <a:bodyPr rtlCol="0" anchor="ctr" wrap="none"/>
           <a:lstStyle/>
           <a:p>
             <a:pPr algn="ctr">
@@ -10227,7 +10107,6 @@
           <a:lstStyle/>
           <a:p>
             <a:pPr algn="ctr"/>
-            <a:endParaRPr/>
           </a:p>
         </p:txBody>
       </p:sp>
@@ -10273,7 +10152,6 @@
           <a:lstStyle/>
           <a:p>
             <a:pPr algn="ctr"/>
-            <a:endParaRPr/>
           </a:p>
         </p:txBody>
       </p:sp>
@@ -10315,7 +10193,7 @@
           </a:fontRef>
         </p:style>
         <p:txBody>
-          <a:bodyPr wrap="none" rtlCol="0" anchor="ctr"/>
+          <a:bodyPr rtlCol="0" anchor="ctr" wrap="none"/>
           <a:lstStyle/>
           <a:p>
             <a:pPr algn="ctr">
@@ -10414,7 +10292,6 @@
           <a:lstStyle/>
           <a:p>
             <a:pPr algn="ctr"/>
-            <a:endParaRPr/>
           </a:p>
         </p:txBody>
       </p:sp>
@@ -10538,7 +10415,6 @@
           <a:lstStyle/>
           <a:p>
             <a:pPr algn="ctr"/>
-            <a:endParaRPr/>
           </a:p>
         </p:txBody>
       </p:sp>
@@ -10584,7 +10460,6 @@
           <a:lstStyle/>
           <a:p>
             <a:pPr algn="ctr"/>
-            <a:endParaRPr/>
           </a:p>
         </p:txBody>
       </p:sp>
@@ -10626,7 +10501,7 @@
           </a:fontRef>
         </p:style>
         <p:txBody>
-          <a:bodyPr wrap="none" rtlCol="0" anchor="ctr"/>
+          <a:bodyPr rtlCol="0" anchor="ctr" wrap="none"/>
           <a:lstStyle/>
           <a:p>
             <a:pPr algn="ctr">
@@ -10725,7 +10600,6 @@
           <a:lstStyle/>
           <a:p>
             <a:pPr algn="ctr"/>
-            <a:endParaRPr/>
           </a:p>
         </p:txBody>
       </p:sp>
@@ -10849,7 +10723,6 @@
           <a:lstStyle/>
           <a:p>
             <a:pPr algn="ctr"/>
-            <a:endParaRPr/>
           </a:p>
         </p:txBody>
       </p:sp>
@@ -10895,7 +10768,6 @@
           <a:lstStyle/>
           <a:p>
             <a:pPr algn="ctr"/>
-            <a:endParaRPr/>
           </a:p>
         </p:txBody>
       </p:sp>
@@ -10937,7 +10809,7 @@
           </a:fontRef>
         </p:style>
         <p:txBody>
-          <a:bodyPr wrap="none" rtlCol="0" anchor="ctr"/>
+          <a:bodyPr rtlCol="0" anchor="ctr" wrap="none"/>
           <a:lstStyle/>
           <a:p>
             <a:pPr algn="ctr">
@@ -11036,7 +10908,6 @@
           <a:lstStyle/>
           <a:p>
             <a:pPr algn="ctr"/>
-            <a:endParaRPr/>
           </a:p>
         </p:txBody>
       </p:sp>
@@ -11160,7 +11031,6 @@
           <a:lstStyle/>
           <a:p>
             <a:pPr algn="ctr"/>
-            <a:endParaRPr/>
           </a:p>
         </p:txBody>
       </p:sp>
@@ -11206,7 +11076,6 @@
           <a:lstStyle/>
           <a:p>
             <a:pPr algn="ctr"/>
-            <a:endParaRPr/>
           </a:p>
         </p:txBody>
       </p:sp>
@@ -11248,7 +11117,7 @@
           </a:fontRef>
         </p:style>
         <p:txBody>
-          <a:bodyPr wrap="none" rtlCol="0" anchor="ctr"/>
+          <a:bodyPr rtlCol="0" anchor="ctr" wrap="none"/>
           <a:lstStyle/>
           <a:p>
             <a:pPr algn="ctr">
@@ -11347,7 +11216,6 @@
           <a:lstStyle/>
           <a:p>
             <a:pPr algn="ctr"/>
-            <a:endParaRPr/>
           </a:p>
         </p:txBody>
       </p:sp>
@@ -11471,7 +11339,6 @@
           <a:lstStyle/>
           <a:p>
             <a:pPr algn="ctr"/>
-            <a:endParaRPr/>
           </a:p>
         </p:txBody>
       </p:sp>
@@ -11517,7 +11384,6 @@
           <a:lstStyle/>
           <a:p>
             <a:pPr algn="ctr"/>
-            <a:endParaRPr/>
           </a:p>
         </p:txBody>
       </p:sp>
@@ -11559,7 +11425,7 @@
           </a:fontRef>
         </p:style>
         <p:txBody>
-          <a:bodyPr wrap="none" rtlCol="0" anchor="ctr"/>
+          <a:bodyPr rtlCol="0" anchor="ctr" wrap="none"/>
           <a:lstStyle/>
           <a:p>
             <a:pPr algn="ctr">
@@ -11658,7 +11524,6 @@
           <a:lstStyle/>
           <a:p>
             <a:pPr algn="ctr"/>
-            <a:endParaRPr/>
           </a:p>
         </p:txBody>
       </p:sp>
@@ -11784,7 +11649,6 @@
           <a:lstStyle/>
           <a:p>
             <a:pPr algn="ctr"/>
-            <a:endParaRPr/>
           </a:p>
         </p:txBody>
       </p:sp>
@@ -11825,7 +11689,7 @@
               </a:defRPr>
             </a:pPr>
             <a:r>
-              <a:t>DATA FLOW:  Live Telemetry  →  Graph Mapping  →  Counterfactual Generation  →  Agent Testing  →  Autonomous Deployment   │  5 LAYERS  •  0 RESEARCH BETS</a:t>
+              <a:t>DATA FLOW:  Live Telemetry  →  Graph Mapping  →  Counterfactual Projection  →  Agent Selection  →  Remediation Recommendation (not deployed)   │  5 LAYERS</a:t>
             </a:r>
           </a:p>
         </p:txBody>
@@ -11839,7 +11703,7 @@
 </file>
 
 <file path=ppt/slides/slide13.xml><?xml version="1.0" encoding="utf-8"?>
-<p:sld xmlns:a="http://schemas.openxmlformats.org/drawingml/2006/main" xmlns:r="http://schemas.openxmlformats.org/officeDocument/2006/relationships" xmlns:p="http://schemas.openxmlformats.org/presentationml/2006/main">
+<p:sld xmlns:a="http://schemas.openxmlformats.org/drawingml/2006/main" xmlns:p="http://schemas.openxmlformats.org/presentationml/2006/main" xmlns:r="http://schemas.openxmlformats.org/officeDocument/2006/relationships">
   <p:cSld>
     <p:bg>
       <p:bgPr>
@@ -11855,14 +11719,7 @@
         <p:cNvGrpSpPr/>
         <p:nvPr/>
       </p:nvGrpSpPr>
-      <p:grpSpPr>
-        <a:xfrm>
-          <a:off x="0" y="0"/>
-          <a:ext cx="0" cy="0"/>
-          <a:chOff x="0" y="0"/>
-          <a:chExt cx="0" cy="0"/>
-        </a:xfrm>
-      </p:grpSpPr>
+      <p:grpSpPr/>
       <p:sp>
         <p:nvSpPr>
           <p:cNvPr id="2" name="Rectangle 1"/>
@@ -11903,7 +11760,6 @@
           <a:lstStyle/>
           <a:p>
             <a:pPr algn="ctr"/>
-            <a:endParaRPr/>
           </a:p>
         </p:txBody>
       </p:sp>
@@ -12029,7 +11885,7 @@
           </a:fontRef>
         </p:style>
         <p:txBody>
-          <a:bodyPr wrap="none" rtlCol="0" anchor="ctr"/>
+          <a:bodyPr rtlCol="0" anchor="ctr" wrap="none"/>
           <a:lstStyle/>
           <a:p>
             <a:pPr algn="ctr">
@@ -12128,7 +11984,6 @@
           <a:lstStyle/>
           <a:p>
             <a:pPr algn="ctr"/>
-            <a:endParaRPr/>
           </a:p>
         </p:txBody>
       </p:sp>
@@ -12216,7 +12071,6 @@
           <a:lstStyle/>
           <a:p>
             <a:pPr algn="ctr"/>
-            <a:endParaRPr/>
           </a:p>
         </p:txBody>
       </p:sp>
@@ -12256,7 +12110,7 @@
           </a:fontRef>
         </p:style>
         <p:txBody>
-          <a:bodyPr wrap="none" rtlCol="0" anchor="ctr"/>
+          <a:bodyPr rtlCol="0" anchor="ctr" wrap="none"/>
           <a:lstStyle/>
           <a:p>
             <a:pPr algn="ctr">
@@ -12359,7 +12213,7 @@
           </a:fontRef>
         </p:style>
         <p:txBody>
-          <a:bodyPr wrap="none" rtlCol="0" anchor="ctr"/>
+          <a:bodyPr rtlCol="0" anchor="ctr" wrap="none"/>
           <a:lstStyle/>
           <a:p>
             <a:pPr algn="ctr">
@@ -12371,7 +12225,7 @@
               </a:defRPr>
             </a:pPr>
             <a:r>
-              <a:t>~1s</a:t>
+              <a:t>live</a:t>
             </a:r>
           </a:p>
         </p:txBody>
@@ -12466,7 +12320,6 @@
           <a:lstStyle/>
           <a:p>
             <a:pPr algn="ctr"/>
-            <a:endParaRPr/>
           </a:p>
         </p:txBody>
       </p:sp>
@@ -12512,7 +12365,6 @@
           <a:lstStyle/>
           <a:p>
             <a:pPr algn="ctr"/>
-            <a:endParaRPr/>
           </a:p>
         </p:txBody>
       </p:sp>
@@ -12552,7 +12404,7 @@
           </a:fontRef>
         </p:style>
         <p:txBody>
-          <a:bodyPr wrap="none" rtlCol="0" anchor="ctr"/>
+          <a:bodyPr rtlCol="0" anchor="ctr" wrap="none"/>
           <a:lstStyle/>
           <a:p>
             <a:pPr algn="ctr">
@@ -12625,7 +12477,7 @@
         </p:nvSpPr>
         <p:spPr>
           <a:xfrm>
-            <a:off x="5249485" y="2368296"/>
+            <a:off x="5166359" y="2377440"/>
             <a:ext cx="640080" cy="292608"/>
           </a:xfrm>
           <a:prstGeom prst="roundRect">
@@ -12655,7 +12507,7 @@
           </a:fontRef>
         </p:style>
         <p:txBody>
-          <a:bodyPr wrap="none" rtlCol="0" anchor="ctr"/>
+          <a:bodyPr rtlCol="0" anchor="ctr" wrap="none"/>
           <a:lstStyle/>
           <a:p>
             <a:pPr algn="ctr">
@@ -12667,7 +12519,7 @@
               </a:defRPr>
             </a:pPr>
             <a:r>
-              <a:t>~2s</a:t>
+              <a:t>ms</a:t>
             </a:r>
           </a:p>
         </p:txBody>
@@ -12766,7 +12618,6 @@
           <a:lstStyle/>
           <a:p>
             <a:pPr algn="ctr"/>
-            <a:endParaRPr/>
           </a:p>
         </p:txBody>
       </p:sp>
@@ -12812,7 +12663,6 @@
           <a:lstStyle/>
           <a:p>
             <a:pPr algn="ctr"/>
-            <a:endParaRPr/>
           </a:p>
         </p:txBody>
       </p:sp>
@@ -12852,7 +12702,7 @@
           </a:fontRef>
         </p:style>
         <p:txBody>
-          <a:bodyPr wrap="none" rtlCol="0" anchor="ctr"/>
+          <a:bodyPr rtlCol="0" anchor="ctr" wrap="none"/>
           <a:lstStyle/>
           <a:p>
             <a:pPr algn="ctr">
@@ -12912,7 +12762,7 @@
               </a:defRPr>
             </a:pPr>
             <a:r>
-              <a:t>SIMULATE</a:t>
+              <a:t>SELECT</a:t>
             </a:r>
           </a:p>
         </p:txBody>
@@ -12925,7 +12775,7 @@
         </p:nvSpPr>
         <p:spPr>
           <a:xfrm>
-            <a:off x="8001000" y="2368296"/>
+            <a:off x="7955279" y="2377440"/>
             <a:ext cx="640080" cy="292608"/>
           </a:xfrm>
           <a:prstGeom prst="roundRect">
@@ -12955,7 +12805,7 @@
           </a:fontRef>
         </p:style>
         <p:txBody>
-          <a:bodyPr wrap="none" rtlCol="0" anchor="ctr"/>
+          <a:bodyPr rtlCol="0" anchor="ctr" wrap="none"/>
           <a:lstStyle/>
           <a:p>
             <a:pPr algn="ctr">
@@ -12967,8 +12817,7 @@
               </a:defRPr>
             </a:pPr>
             <a:r>
-              <a:rPr dirty="0"/>
-              <a:t>~2s</a:t>
+              <a:t>ms</a:t>
             </a:r>
           </a:p>
         </p:txBody>
@@ -13018,11 +12867,11 @@
             </a:r>
             <a:br/>
             <a:r>
-              <a:t>Agent 2: Increasing laser bias</a:t>
+              <a:t>Agent 2 picks the best</a:t>
             </a:r>
             <a:br/>
             <a:r>
-              <a:t>stabilizes OSNR for 6+ months.</a:t>
+              <a:t>projection (not time-validated).</a:t>
             </a:r>
           </a:p>
         </p:txBody>
@@ -13067,7 +12916,6 @@
           <a:lstStyle/>
           <a:p>
             <a:pPr algn="ctr"/>
-            <a:endParaRPr/>
           </a:p>
         </p:txBody>
       </p:sp>
@@ -13113,7 +12961,6 @@
           <a:lstStyle/>
           <a:p>
             <a:pPr algn="ctr"/>
-            <a:endParaRPr/>
           </a:p>
         </p:txBody>
       </p:sp>
@@ -13153,7 +13000,7 @@
           </a:fontRef>
         </p:style>
         <p:txBody>
-          <a:bodyPr wrap="none" rtlCol="0" anchor="ctr"/>
+          <a:bodyPr rtlCol="0" anchor="ctr" wrap="none"/>
           <a:lstStyle/>
           <a:p>
             <a:pPr algn="ctr">
@@ -13213,7 +13060,7 @@
               </a:defRPr>
             </a:pPr>
             <a:r>
-              <a:t>DEPLOY</a:t>
+              <a:t>RECOMMEND</a:t>
             </a:r>
           </a:p>
         </p:txBody>
@@ -13256,7 +13103,7 @@
           </a:fontRef>
         </p:style>
         <p:txBody>
-          <a:bodyPr wrap="none" rtlCol="0" anchor="ctr"/>
+          <a:bodyPr rtlCol="0" anchor="ctr" wrap="none"/>
           <a:lstStyle/>
           <a:p>
             <a:pPr algn="ctr">
@@ -13268,7 +13115,7 @@
               </a:defRPr>
             </a:pPr>
             <a:r>
-              <a:t>~5s</a:t>
+              <a:t>only</a:t>
             </a:r>
           </a:p>
         </p:txBody>
@@ -13310,7 +13157,7 @@
               </a:defRPr>
             </a:pPr>
             <a:r>
-              <a:t>Agent 3 generates NETCONF/</a:t>
+              <a:t>Agent 3 generates a NETCONF/</a:t>
             </a:r>
             <a:br/>
             <a:r>
@@ -13318,11 +13165,11 @@
             </a:r>
             <a:br/>
             <a:r>
-              <a:t>bias. Validator approves.</a:t>
+              <a:t>bias as a RECOMMENDATION.</a:t>
             </a:r>
             <a:br/>
             <a:r>
-              <a:t>Pushed live via API.</a:t>
+              <a:t>Not auto-deployed.</a:t>
             </a:r>
           </a:p>
         </p:txBody>
@@ -13365,7 +13212,7 @@
           </a:fontRef>
         </p:style>
         <p:txBody>
-          <a:bodyPr wrap="none" rtlCol="0" anchor="ctr"/>
+          <a:bodyPr rtlCol="0" anchor="ctr" wrap="none"/>
           <a:lstStyle/>
           <a:p>
             <a:pPr algn="ctr">
@@ -13420,7 +13267,7 @@
           </a:fontRef>
         </p:style>
         <p:txBody>
-          <a:bodyPr wrap="none" rtlCol="0" anchor="ctr"/>
+          <a:bodyPr rtlCol="0" anchor="ctr" wrap="none"/>
           <a:lstStyle/>
           <a:p>
             <a:pPr algn="ctr">
@@ -13475,7 +13322,7 @@
           </a:fontRef>
         </p:style>
         <p:txBody>
-          <a:bodyPr wrap="none" rtlCol="0" anchor="ctr"/>
+          <a:bodyPr rtlCol="0" anchor="ctr" wrap="none"/>
           <a:lstStyle/>
           <a:p>
             <a:pPr algn="ctr">
@@ -13530,7 +13377,7 @@
           </a:fontRef>
         </p:style>
         <p:txBody>
-          <a:bodyPr wrap="none" rtlCol="0" anchor="ctr"/>
+          <a:bodyPr rtlCol="0" anchor="ctr" wrap="none"/>
           <a:lstStyle/>
           <a:p>
             <a:pPr algn="ctr">
@@ -13589,7 +13436,6 @@
           <a:lstStyle/>
           <a:p>
             <a:pPr algn="ctr"/>
-            <a:endParaRPr/>
           </a:p>
         </p:txBody>
       </p:sp>
@@ -13630,7 +13476,7 @@
               </a:defRPr>
             </a:pPr>
             <a:r>
-              <a:t>RESULT:  Software fix deployed autonomously — no service interruption, no hardware replacement, equipment life extended 6 months. Total time: &lt; 10 seconds.</a:t>
+              <a:t>RESULT:  Remediation RECOMMENDATION generated. In the prototype the command is NOT auto-deployed; no service-interruption or equipment-life claims are made without live validation.</a:t>
             </a:r>
           </a:p>
         </p:txBody>
@@ -13644,7 +13490,7 @@
 </file>
 
 <file path=ppt/slides/slide14.xml><?xml version="1.0" encoding="utf-8"?>
-<p:sld xmlns:a="http://schemas.openxmlformats.org/drawingml/2006/main" xmlns:r="http://schemas.openxmlformats.org/officeDocument/2006/relationships" xmlns:p="http://schemas.openxmlformats.org/presentationml/2006/main">
+<p:sld xmlns:a="http://schemas.openxmlformats.org/drawingml/2006/main" xmlns:p="http://schemas.openxmlformats.org/presentationml/2006/main" xmlns:r="http://schemas.openxmlformats.org/officeDocument/2006/relationships">
   <p:cSld>
     <p:bg>
       <p:bgPr>
@@ -13660,14 +13506,7 @@
         <p:cNvGrpSpPr/>
         <p:nvPr/>
       </p:nvGrpSpPr>
-      <p:grpSpPr>
-        <a:xfrm>
-          <a:off x="0" y="0"/>
-          <a:ext cx="0" cy="0"/>
-          <a:chOff x="0" y="0"/>
-          <a:chExt cx="0" cy="0"/>
-        </a:xfrm>
-      </p:grpSpPr>
+      <p:grpSpPr/>
       <p:sp>
         <p:nvSpPr>
           <p:cNvPr id="2" name="Rectangle 1"/>
@@ -13708,7 +13547,6 @@
           <a:lstStyle/>
           <a:p>
             <a:pPr algn="ctr"/>
-            <a:endParaRPr/>
           </a:p>
         </p:txBody>
       </p:sp>
@@ -13834,7 +13672,7 @@
           </a:fontRef>
         </p:style>
         <p:txBody>
-          <a:bodyPr wrap="none" rtlCol="0" anchor="ctr"/>
+          <a:bodyPr rtlCol="0" anchor="ctr" wrap="none"/>
           <a:lstStyle/>
           <a:p>
             <a:pPr algn="ctr">
@@ -13933,7 +13771,6 @@
           <a:lstStyle/>
           <a:p>
             <a:pPr algn="ctr"/>
-            <a:endParaRPr/>
           </a:p>
         </p:txBody>
       </p:sp>
@@ -13979,7 +13816,6 @@
           <a:lstStyle/>
           <a:p>
             <a:pPr algn="ctr"/>
-            <a:endParaRPr/>
           </a:p>
         </p:txBody>
       </p:sp>
@@ -14020,7 +13856,7 @@
               </a:defRPr>
             </a:pPr>
             <a:r>
-              <a:t>&lt; 10</a:t>
+              <a:t>&lt; few</a:t>
             </a:r>
           </a:p>
         </p:txBody>
@@ -14062,7 +13898,7 @@
               </a:defRPr>
             </a:pPr>
             <a:r>
-              <a:t>SECONDS</a:t>
+              <a:t>ms</a:t>
             </a:r>
           </a:p>
         </p:txBody>
@@ -14107,7 +13943,6 @@
           <a:lstStyle/>
           <a:p>
             <a:pPr algn="ctr"/>
-            <a:endParaRPr/>
           </a:p>
         </p:txBody>
       </p:sp>
@@ -14148,7 +13983,7 @@
               </a:defRPr>
             </a:pPr>
             <a:r>
-              <a:t>MTTR Reduction</a:t>
+              <a:t>Decision Compute</a:t>
             </a:r>
           </a:p>
         </p:txBody>
@@ -14190,11 +14025,11 @@
               </a:defRPr>
             </a:pPr>
             <a:r>
-              <a:t>From hours/days to</a:t>
+              <a:t>In-process compute only</a:t>
             </a:r>
             <a:br/>
             <a:r>
-              <a:t>single-digit seconds</a:t>
+              <a:t>(excludes LLM &amp; deployment)</a:t>
             </a:r>
           </a:p>
         </p:txBody>
@@ -14241,7 +14076,6 @@
           <a:lstStyle/>
           <a:p>
             <a:pPr algn="ctr"/>
-            <a:endParaRPr/>
           </a:p>
         </p:txBody>
       </p:sp>
@@ -14282,7 +14116,7 @@
               </a:defRPr>
             </a:pPr>
             <a:r>
-              <a:t>40%</a:t>
+              <a:t>POTENTIAL</a:t>
             </a:r>
           </a:p>
         </p:txBody>
@@ -14324,7 +14158,7 @@
               </a:defRPr>
             </a:pPr>
             <a:r>
-              <a:t>SAVINGS</a:t>
+              <a:t>OPEX</a:t>
             </a:r>
           </a:p>
         </p:txBody>
@@ -14369,7 +14203,6 @@
           <a:lstStyle/>
           <a:p>
             <a:pPr algn="ctr"/>
-            <a:endParaRPr/>
           </a:p>
         </p:txBody>
       </p:sp>
@@ -14410,7 +14243,7 @@
               </a:defRPr>
             </a:pPr>
             <a:r>
-              <a:t>OPEX Reduction</a:t>
+              <a:t>Truck-Roll Savings</a:t>
             </a:r>
           </a:p>
         </p:txBody>
@@ -14452,11 +14285,11 @@
               </a:defRPr>
             </a:pPr>
             <a:r>
-              <a:t>Eliminates unnecessary</a:t>
+              <a:t>Not yet measured;</a:t>
             </a:r>
             <a:br/>
             <a:r>
-              <a:t>hardware truck rolls</a:t>
+              <a:t>projected benefit only</a:t>
             </a:r>
           </a:p>
         </p:txBody>
@@ -14503,7 +14336,6 @@
           <a:lstStyle/>
           <a:p>
             <a:pPr algn="ctr"/>
-            <a:endParaRPr/>
           </a:p>
         </p:txBody>
       </p:sp>
@@ -14544,7 +14376,7 @@
               </a:defRPr>
             </a:pPr>
             <a:r>
-              <a:t>100%</a:t>
+              <a:t>RECOMMEND</a:t>
             </a:r>
           </a:p>
         </p:txBody>
@@ -14586,7 +14418,7 @@
               </a:defRPr>
             </a:pPr>
             <a:r>
-              <a:t>VALIDATED</a:t>
+              <a:t>ONLY</a:t>
             </a:r>
           </a:p>
         </p:txBody>
@@ -14631,7 +14463,6 @@
           <a:lstStyle/>
           <a:p>
             <a:pPr algn="ctr"/>
-            <a:endParaRPr/>
           </a:p>
         </p:txBody>
       </p:sp>
@@ -14672,7 +14503,7 @@
               </a:defRPr>
             </a:pPr>
             <a:r>
-              <a:t>Zero-Risk Fixes</a:t>
+              <a:t>Safety Model</a:t>
             </a:r>
           </a:p>
         </p:txBody>
@@ -14714,11 +14545,11 @@
               </a:defRPr>
             </a:pPr>
             <a:r>
-              <a:t>All fixes proven safe in</a:t>
+              <a:t>Commands are recommended,</a:t>
             </a:r>
             <a:br/>
             <a:r>
-              <a:t>digital twin first</a:t>
+              <a:t>not auto-deployed</a:t>
             </a:r>
           </a:p>
         </p:txBody>
@@ -14765,7 +14596,6 @@
           <a:lstStyle/>
           <a:p>
             <a:pPr algn="ctr"/>
-            <a:endParaRPr/>
           </a:p>
         </p:txBody>
       </p:sp>
@@ -14893,7 +14723,6 @@
           <a:lstStyle/>
           <a:p>
             <a:pPr algn="ctr"/>
-            <a:endParaRPr/>
           </a:p>
         </p:txBody>
       </p:sp>
@@ -14976,11 +14805,11 @@
               </a:defRPr>
             </a:pPr>
             <a:r>
-              <a:t>Stops failures from</a:t>
+              <a:t>Claim—not yet validated</a:t>
             </a:r>
             <a:br/>
             <a:r>
-              <a:t>spreading across topology</a:t>
+              <a:t>on live infrastructure</a:t>
             </a:r>
           </a:p>
         </p:txBody>
@@ -15027,7 +14856,6 @@
           <a:lstStyle/>
           <a:p>
             <a:pPr algn="ctr"/>
-            <a:endParaRPr/>
           </a:p>
         </p:txBody>
       </p:sp>
@@ -15153,7 +14981,7 @@
           </a:fontRef>
         </p:style>
         <p:txBody>
-          <a:bodyPr wrap="none" rtlCol="0" anchor="ctr"/>
+          <a:bodyPr rtlCol="0" anchor="ctr" wrap="none"/>
           <a:lstStyle/>
           <a:p>
             <a:pPr algn="ctr">
@@ -15165,7 +14993,7 @@
               </a:defRPr>
             </a:pPr>
             <a:r>
-              <a:t>FID &lt; 50</a:t>
+              <a:t>TARGET FID &lt; 50</a:t>
             </a:r>
           </a:p>
         </p:txBody>
@@ -15207,7 +15035,7 @@
               </a:defRPr>
             </a:pPr>
             <a:r>
-              <a:t>Synthetic vs. real telemetry fidelity</a:t>
+              <a:t>Target only; measured FID is currently far higher (poor on synthetic prior)</a:t>
             </a:r>
           </a:p>
         </p:txBody>
@@ -15292,7 +15120,7 @@
           </a:fontRef>
         </p:style>
         <p:txBody>
-          <a:bodyPr wrap="none" rtlCol="0" anchor="ctr"/>
+          <a:bodyPr rtlCol="0" anchor="ctr" wrap="none"/>
           <a:lstStyle/>
           <a:p>
             <a:pPr algn="ctr">
@@ -15304,7 +15132,7 @@
               </a:defRPr>
             </a:pPr>
             <a:r>
-              <a:t>≥ 95%</a:t>
+              <a:t>VCG-maximizing</a:t>
             </a:r>
           </a:p>
         </p:txBody>
@@ -15346,7 +15174,7 @@
               </a:defRPr>
             </a:pPr>
             <a:r>
-              <a:t>VCG social welfare vs. brute-force optimal</a:t>
+              <a:t>VCG assignment maximizes social welfare of stated bids (exact on given bids)</a:t>
             </a:r>
           </a:p>
         </p:txBody>
@@ -15388,7 +15216,7 @@
               </a:defRPr>
             </a:pPr>
             <a:r>
-              <a:t>Model Inference</a:t>
+              <a:t>Decision Compute</a:t>
             </a:r>
           </a:p>
         </p:txBody>
@@ -15431,7 +15259,7 @@
           </a:fontRef>
         </p:style>
         <p:txBody>
-          <a:bodyPr wrap="none" rtlCol="0" anchor="ctr"/>
+          <a:bodyPr rtlCol="0" anchor="ctr" wrap="none"/>
           <a:lstStyle/>
           <a:p>
             <a:pPr algn="ctr">
@@ -15443,7 +15271,7 @@
               </a:defRPr>
             </a:pPr>
             <a:r>
-              <a:t>&lt; 500ms</a:t>
+              <a:t>ms</a:t>
             </a:r>
           </a:p>
         </p:txBody>
@@ -15485,7 +15313,7 @@
               </a:defRPr>
             </a:pPr>
             <a:r>
-              <a:t>Per-component end-to-end latency</a:t>
+              <a:t>In-process compute only; excludes LLM &amp; deployment</a:t>
             </a:r>
           </a:p>
         </p:txBody>
@@ -15499,7 +15327,7 @@
 </file>
 
 <file path=ppt/slides/slide15.xml><?xml version="1.0" encoding="utf-8"?>
-<p:sld xmlns:a="http://schemas.openxmlformats.org/drawingml/2006/main" xmlns:r="http://schemas.openxmlformats.org/officeDocument/2006/relationships" xmlns:p="http://schemas.openxmlformats.org/presentationml/2006/main">
+<p:sld xmlns:a="http://schemas.openxmlformats.org/drawingml/2006/main" xmlns:p="http://schemas.openxmlformats.org/presentationml/2006/main" xmlns:r="http://schemas.openxmlformats.org/officeDocument/2006/relationships">
   <p:cSld>
     <p:bg>
       <p:bgPr>
@@ -15515,14 +15343,7 @@
         <p:cNvGrpSpPr/>
         <p:nvPr/>
       </p:nvGrpSpPr>
-      <p:grpSpPr>
-        <a:xfrm>
-          <a:off x="0" y="0"/>
-          <a:ext cx="0" cy="0"/>
-          <a:chOff x="0" y="0"/>
-          <a:chExt cx="0" cy="0"/>
-        </a:xfrm>
-      </p:grpSpPr>
+      <p:grpSpPr/>
       <p:sp>
         <p:nvSpPr>
           <p:cNvPr id="2" name="Rectangle 1"/>
@@ -15563,7 +15384,6 @@
           <a:lstStyle/>
           <a:p>
             <a:pPr algn="ctr"/>
-            <a:endParaRPr/>
           </a:p>
         </p:txBody>
       </p:sp>
@@ -15689,7 +15509,7 @@
           </a:fontRef>
         </p:style>
         <p:txBody>
-          <a:bodyPr wrap="none" rtlCol="0" anchor="ctr"/>
+          <a:bodyPr rtlCol="0" anchor="ctr" wrap="none"/>
           <a:lstStyle/>
           <a:p>
             <a:pPr algn="ctr">
@@ -15788,7 +15608,6 @@
           <a:lstStyle/>
           <a:p>
             <a:pPr algn="ctr"/>
-            <a:endParaRPr/>
           </a:p>
         </p:txBody>
       </p:sp>
@@ -15876,7 +15695,6 @@
           <a:lstStyle/>
           <a:p>
             <a:pPr algn="ctr"/>
-            <a:endParaRPr/>
           </a:p>
         </p:txBody>
       </p:sp>
@@ -15918,7 +15736,7 @@
           </a:fontRef>
         </p:style>
         <p:txBody>
-          <a:bodyPr wrap="none" rtlCol="0" anchor="ctr"/>
+          <a:bodyPr rtlCol="0" anchor="ctr" wrap="none"/>
           <a:lstStyle/>
           <a:p>
             <a:pPr algn="ctr">
@@ -15973,7 +15791,7 @@
           </a:fontRef>
         </p:style>
         <p:txBody>
-          <a:bodyPr wrap="none" rtlCol="0" anchor="ctr"/>
+          <a:bodyPr rtlCol="0" anchor="ctr" wrap="none"/>
           <a:lstStyle/>
           <a:p>
             <a:pPr algn="ctr">
@@ -16114,7 +15932,6 @@
           <a:lstStyle/>
           <a:p>
             <a:pPr algn="ctr"/>
-            <a:endParaRPr/>
           </a:p>
         </p:txBody>
       </p:sp>
@@ -16216,7 +16033,6 @@
           <a:lstStyle/>
           <a:p>
             <a:pPr algn="ctr"/>
-            <a:endParaRPr/>
           </a:p>
         </p:txBody>
       </p:sp>
@@ -16262,7 +16078,6 @@
           <a:lstStyle/>
           <a:p>
             <a:pPr algn="ctr"/>
-            <a:endParaRPr/>
           </a:p>
         </p:txBody>
       </p:sp>
@@ -16304,7 +16119,7 @@
           </a:fontRef>
         </p:style>
         <p:txBody>
-          <a:bodyPr wrap="none" rtlCol="0" anchor="ctr"/>
+          <a:bodyPr rtlCol="0" anchor="ctr" wrap="none"/>
           <a:lstStyle/>
           <a:p>
             <a:pPr algn="ctr">
@@ -16359,7 +16174,7 @@
           </a:fontRef>
         </p:style>
         <p:txBody>
-          <a:bodyPr wrap="none" rtlCol="0" anchor="ctr"/>
+          <a:bodyPr rtlCol="0" anchor="ctr" wrap="none"/>
           <a:lstStyle/>
           <a:p>
             <a:pPr algn="ctr">
@@ -16500,7 +16315,6 @@
           <a:lstStyle/>
           <a:p>
             <a:pPr algn="ctr"/>
-            <a:endParaRPr/>
           </a:p>
         </p:txBody>
       </p:sp>
@@ -16602,7 +16416,6 @@
           <a:lstStyle/>
           <a:p>
             <a:pPr algn="ctr"/>
-            <a:endParaRPr/>
           </a:p>
         </p:txBody>
       </p:sp>
@@ -16648,7 +16461,6 @@
           <a:lstStyle/>
           <a:p>
             <a:pPr algn="ctr"/>
-            <a:endParaRPr/>
           </a:p>
         </p:txBody>
       </p:sp>
@@ -16690,7 +16502,7 @@
           </a:fontRef>
         </p:style>
         <p:txBody>
-          <a:bodyPr wrap="none" rtlCol="0" anchor="ctr"/>
+          <a:bodyPr rtlCol="0" anchor="ctr" wrap="none"/>
           <a:lstStyle/>
           <a:p>
             <a:pPr algn="ctr">
@@ -16745,7 +16557,7 @@
           </a:fontRef>
         </p:style>
         <p:txBody>
-          <a:bodyPr wrap="none" rtlCol="0" anchor="ctr"/>
+          <a:bodyPr rtlCol="0" anchor="ctr" wrap="none"/>
           <a:lstStyle/>
           <a:p>
             <a:pPr algn="ctr">
@@ -16886,7 +16698,6 @@
           <a:lstStyle/>
           <a:p>
             <a:pPr algn="ctr"/>
-            <a:endParaRPr/>
           </a:p>
         </p:txBody>
       </p:sp>
@@ -16990,7 +16801,6 @@
           <a:lstStyle/>
           <a:p>
             <a:pPr algn="ctr"/>
-            <a:endParaRPr/>
           </a:p>
         </p:txBody>
       </p:sp>
@@ -17045,7 +16855,7 @@
 </file>
 
 <file path=ppt/slides/slide2.xml><?xml version="1.0" encoding="utf-8"?>
-<p:sld xmlns:a="http://schemas.openxmlformats.org/drawingml/2006/main" xmlns:r="http://schemas.openxmlformats.org/officeDocument/2006/relationships" xmlns:p="http://schemas.openxmlformats.org/presentationml/2006/main">
+<p:sld xmlns:a="http://schemas.openxmlformats.org/drawingml/2006/main" xmlns:p="http://schemas.openxmlformats.org/presentationml/2006/main" xmlns:r="http://schemas.openxmlformats.org/officeDocument/2006/relationships">
   <p:cSld>
     <p:bg>
       <p:bgPr>
@@ -17061,14 +16871,7 @@
         <p:cNvGrpSpPr/>
         <p:nvPr/>
       </p:nvGrpSpPr>
-      <p:grpSpPr>
-        <a:xfrm>
-          <a:off x="0" y="0"/>
-          <a:ext cx="0" cy="0"/>
-          <a:chOff x="0" y="0"/>
-          <a:chExt cx="0" cy="0"/>
-        </a:xfrm>
-      </p:grpSpPr>
+      <p:grpSpPr/>
       <p:sp>
         <p:nvSpPr>
           <p:cNvPr id="2" name="Rectangle 1"/>
@@ -17109,7 +16912,6 @@
           <a:lstStyle/>
           <a:p>
             <a:pPr algn="ctr"/>
-            <a:endParaRPr/>
           </a:p>
         </p:txBody>
       </p:sp>
@@ -17235,7 +17037,7 @@
           </a:fontRef>
         </p:style>
         <p:txBody>
-          <a:bodyPr wrap="none" rtlCol="0" anchor="ctr"/>
+          <a:bodyPr rtlCol="0" anchor="ctr" wrap="none"/>
           <a:lstStyle/>
           <a:p>
             <a:pPr algn="ctr">
@@ -17334,7 +17136,6 @@
           <a:lstStyle/>
           <a:p>
             <a:pPr algn="ctr"/>
-            <a:endParaRPr/>
           </a:p>
         </p:txBody>
       </p:sp>
@@ -17380,7 +17181,6 @@
           <a:lstStyle/>
           <a:p>
             <a:pPr algn="ctr"/>
-            <a:endParaRPr/>
           </a:p>
         </p:txBody>
       </p:sp>
@@ -17440,7 +17240,7 @@
               </a:defRPr>
             </a:pPr>
             <a:r>
-              <a:t>CTG-CPM introduces a novel closed-loop system that leverages Generative AI (Time-Series Diffusion Models) to synthesize hypothetical future network telemetry, Graph Neural Networks (GNNs) to enforce topology-aware constraints, and Multi-Agent Agentic AI to autonomously diagnose, test, and deploy fixes — all within sub-second latency.</a:t>
+              <a:t>CTG-CPM introduces a system that leverages Generative AI (Time-Series Diffusion Models) to project hypothetical future network telemetry, Graph Neural Networks (GNNs) to enforce topology-aware constraints, and Multi-Agent Agentic AI to produce remediation recommendations. Decision compute is sub-millisecond; commands are not auto-deployed in the prototype.</a:t>
             </a:r>
           </a:p>
           <a:p>
@@ -17502,7 +17302,7 @@
           </a:fontRef>
         </p:style>
         <p:txBody>
-          <a:bodyPr wrap="none" rtlCol="0" anchor="ctr"/>
+          <a:bodyPr rtlCol="0" anchor="ctr" wrap="none"/>
           <a:lstStyle/>
           <a:p>
             <a:pPr algn="ctr">
@@ -17514,7 +17314,7 @@
               </a:defRPr>
             </a:pPr>
             <a:r>
-              <a:t>&lt; 10s MTTR</a:t>
+              <a:t>FAST DECISION COMPUTE</a:t>
             </a:r>
           </a:p>
         </p:txBody>
@@ -17557,7 +17357,7 @@
           </a:fontRef>
         </p:style>
         <p:txBody>
-          <a:bodyPr wrap="none" rtlCol="0" anchor="ctr"/>
+          <a:bodyPr rtlCol="0" anchor="ctr" wrap="none"/>
           <a:lstStyle/>
           <a:p>
             <a:pPr algn="ctr">
@@ -17569,7 +17369,7 @@
               </a:defRPr>
             </a:pPr>
             <a:r>
-              <a:t>40% OPEX SAVINGS</a:t>
+              <a:t>POTENTIAL OPEX SAVINGS</a:t>
             </a:r>
           </a:p>
         </p:txBody>
@@ -17612,7 +17412,7 @@
           </a:fontRef>
         </p:style>
         <p:txBody>
-          <a:bodyPr wrap="none" rtlCol="0" anchor="ctr"/>
+          <a:bodyPr rtlCol="0" anchor="ctr" wrap="none"/>
           <a:lstStyle/>
           <a:p>
             <a:pPr algn="ctr">
@@ -17624,7 +17424,7 @@
               </a:defRPr>
             </a:pPr>
             <a:r>
-              <a:t>ZERO-RISK FIXES</a:t>
+              <a:t>RECOMMENDATION-BASED FIXES</a:t>
             </a:r>
           </a:p>
         </p:txBody>
@@ -17667,7 +17467,7 @@
           </a:fontRef>
         </p:style>
         <p:txBody>
-          <a:bodyPr wrap="none" rtlCol="0" anchor="ctr"/>
+          <a:bodyPr rtlCol="0" anchor="ctr" wrap="none"/>
           <a:lstStyle/>
           <a:p>
             <a:pPr algn="ctr">
@@ -17693,7 +17493,7 @@
 </file>
 
 <file path=ppt/slides/slide3.xml><?xml version="1.0" encoding="utf-8"?>
-<p:sld xmlns:a="http://schemas.openxmlformats.org/drawingml/2006/main" xmlns:r="http://schemas.openxmlformats.org/officeDocument/2006/relationships" xmlns:p="http://schemas.openxmlformats.org/presentationml/2006/main">
+<p:sld xmlns:a="http://schemas.openxmlformats.org/drawingml/2006/main" xmlns:p="http://schemas.openxmlformats.org/presentationml/2006/main" xmlns:r="http://schemas.openxmlformats.org/officeDocument/2006/relationships">
   <p:cSld>
     <p:bg>
       <p:bgPr>
@@ -17709,14 +17509,7 @@
         <p:cNvGrpSpPr/>
         <p:nvPr/>
       </p:nvGrpSpPr>
-      <p:grpSpPr>
-        <a:xfrm>
-          <a:off x="0" y="0"/>
-          <a:ext cx="0" cy="0"/>
-          <a:chOff x="0" y="0"/>
-          <a:chExt cx="0" cy="0"/>
-        </a:xfrm>
-      </p:grpSpPr>
+      <p:grpSpPr/>
       <p:sp>
         <p:nvSpPr>
           <p:cNvPr id="2" name="Rectangle 1"/>
@@ -17757,7 +17550,6 @@
           <a:lstStyle/>
           <a:p>
             <a:pPr algn="ctr"/>
-            <a:endParaRPr/>
           </a:p>
         </p:txBody>
       </p:sp>
@@ -17883,7 +17675,7 @@
           </a:fontRef>
         </p:style>
         <p:txBody>
-          <a:bodyPr wrap="none" rtlCol="0" anchor="ctr"/>
+          <a:bodyPr rtlCol="0" anchor="ctr" wrap="none"/>
           <a:lstStyle/>
           <a:p>
             <a:pPr algn="ctr">
@@ -17982,7 +17774,6 @@
           <a:lstStyle/>
           <a:p>
             <a:pPr algn="ctr"/>
-            <a:endParaRPr/>
           </a:p>
         </p:txBody>
       </p:sp>
@@ -18028,7 +17819,6 @@
           <a:lstStyle/>
           <a:p>
             <a:pPr algn="ctr"/>
-            <a:endParaRPr/>
           </a:p>
         </p:txBody>
       </p:sp>
@@ -18070,7 +17860,7 @@
           </a:fontRef>
         </p:style>
         <p:txBody>
-          <a:bodyPr wrap="none" rtlCol="0" anchor="ctr"/>
+          <a:bodyPr rtlCol="0" anchor="ctr" wrap="none"/>
           <a:lstStyle/>
           <a:p>
             <a:pPr algn="ctr">
@@ -18123,7 +17913,7 @@
           </a:fontRef>
         </p:style>
         <p:txBody>
-          <a:bodyPr wrap="none" rtlCol="0" anchor="ctr"/>
+          <a:bodyPr rtlCol="0" anchor="ctr" wrap="none"/>
           <a:lstStyle/>
           <a:p>
             <a:pPr algn="ctr">
@@ -18272,7 +18062,6 @@
           <a:lstStyle/>
           <a:p>
             <a:pPr algn="ctr"/>
-            <a:endParaRPr/>
           </a:p>
         </p:txBody>
       </p:sp>
@@ -18314,7 +18103,7 @@
           </a:fontRef>
         </p:style>
         <p:txBody>
-          <a:bodyPr wrap="none" rtlCol="0" anchor="ctr"/>
+          <a:bodyPr rtlCol="0" anchor="ctr" wrap="none"/>
           <a:lstStyle/>
           <a:p>
             <a:pPr algn="ctr">
@@ -18367,7 +18156,7 @@
           </a:fontRef>
         </p:style>
         <p:txBody>
-          <a:bodyPr wrap="none" rtlCol="0" anchor="ctr"/>
+          <a:bodyPr rtlCol="0" anchor="ctr" wrap="none"/>
           <a:lstStyle/>
           <a:p>
             <a:pPr algn="ctr">
@@ -18516,7 +18305,6 @@
           <a:lstStyle/>
           <a:p>
             <a:pPr algn="ctr"/>
-            <a:endParaRPr/>
           </a:p>
         </p:txBody>
       </p:sp>
@@ -18558,7 +18346,7 @@
           </a:fontRef>
         </p:style>
         <p:txBody>
-          <a:bodyPr wrap="none" rtlCol="0" anchor="ctr"/>
+          <a:bodyPr rtlCol="0" anchor="ctr" wrap="none"/>
           <a:lstStyle/>
           <a:p>
             <a:pPr algn="ctr">
@@ -18611,7 +18399,7 @@
           </a:fontRef>
         </p:style>
         <p:txBody>
-          <a:bodyPr wrap="none" rtlCol="0" anchor="ctr"/>
+          <a:bodyPr rtlCol="0" anchor="ctr" wrap="none"/>
           <a:lstStyle/>
           <a:p>
             <a:pPr algn="ctr">
@@ -18760,7 +18548,6 @@
           <a:lstStyle/>
           <a:p>
             <a:pPr algn="ctr"/>
-            <a:endParaRPr/>
           </a:p>
         </p:txBody>
       </p:sp>
@@ -18815,7 +18602,7 @@
 </file>
 
 <file path=ppt/slides/slide4.xml><?xml version="1.0" encoding="utf-8"?>
-<p:sld xmlns:a="http://schemas.openxmlformats.org/drawingml/2006/main" xmlns:r="http://schemas.openxmlformats.org/officeDocument/2006/relationships" xmlns:p="http://schemas.openxmlformats.org/presentationml/2006/main">
+<p:sld xmlns:a="http://schemas.openxmlformats.org/drawingml/2006/main" xmlns:p="http://schemas.openxmlformats.org/presentationml/2006/main" xmlns:r="http://schemas.openxmlformats.org/officeDocument/2006/relationships">
   <p:cSld>
     <p:bg>
       <p:bgPr>
@@ -18831,14 +18618,7 @@
         <p:cNvGrpSpPr/>
         <p:nvPr/>
       </p:nvGrpSpPr>
-      <p:grpSpPr>
-        <a:xfrm>
-          <a:off x="0" y="0"/>
-          <a:ext cx="0" cy="0"/>
-          <a:chOff x="0" y="0"/>
-          <a:chExt cx="0" cy="0"/>
-        </a:xfrm>
-      </p:grpSpPr>
+      <p:grpSpPr/>
       <p:sp>
         <p:nvSpPr>
           <p:cNvPr id="2" name="Rectangle 1"/>
@@ -18879,7 +18659,6 @@
           <a:lstStyle/>
           <a:p>
             <a:pPr algn="ctr"/>
-            <a:endParaRPr/>
           </a:p>
         </p:txBody>
       </p:sp>
@@ -19005,7 +18784,7 @@
           </a:fontRef>
         </p:style>
         <p:txBody>
-          <a:bodyPr wrap="none" rtlCol="0" anchor="ctr"/>
+          <a:bodyPr rtlCol="0" anchor="ctr" wrap="none"/>
           <a:lstStyle/>
           <a:p>
             <a:pPr algn="ctr">
@@ -19104,7 +18883,6 @@
           <a:lstStyle/>
           <a:p>
             <a:pPr algn="ctr"/>
-            <a:endParaRPr/>
           </a:p>
         </p:txBody>
       </p:sp>
@@ -19145,7 +18923,7 @@
               </a:defRPr>
             </a:pPr>
             <a:r>
-              <a:t>A closed-loop system that generates hypothetical futures, tests fixes in a digital twin, and deploys the verified fix autonomously.</a:t>
+              <a:t>A system that generates counterfactual futures, evaluates candidate remediations, and produces a RECOMMENDED command (not auto-deployed in the prototype).</a:t>
             </a:r>
           </a:p>
         </p:txBody>
@@ -19192,7 +18970,6 @@
           <a:lstStyle/>
           <a:p>
             <a:pPr algn="ctr"/>
-            <a:endParaRPr/>
           </a:p>
         </p:txBody>
       </p:sp>
@@ -19234,7 +19011,7 @@
           </a:fontRef>
         </p:style>
         <p:txBody>
-          <a:bodyPr wrap="none" rtlCol="0" anchor="ctr"/>
+          <a:bodyPr rtlCol="0" anchor="ctr" wrap="none"/>
           <a:lstStyle/>
           <a:p>
             <a:pPr algn="ctr">
@@ -19287,7 +19064,7 @@
           </a:fontRef>
         </p:style>
         <p:txBody>
-          <a:bodyPr wrap="none" rtlCol="0" anchor="ctr"/>
+          <a:bodyPr rtlCol="0" anchor="ctr" wrap="none"/>
           <a:lstStyle/>
           <a:p>
             <a:pPr algn="ctr">
@@ -19436,7 +19213,6 @@
           <a:lstStyle/>
           <a:p>
             <a:pPr algn="ctr"/>
-            <a:endParaRPr/>
           </a:p>
         </p:txBody>
       </p:sp>
@@ -19478,7 +19254,7 @@
           </a:fontRef>
         </p:style>
         <p:txBody>
-          <a:bodyPr wrap="none" rtlCol="0" anchor="ctr"/>
+          <a:bodyPr rtlCol="0" anchor="ctr" wrap="none"/>
           <a:lstStyle/>
           <a:p>
             <a:pPr algn="ctr">
@@ -19531,7 +19307,7 @@
           </a:fontRef>
         </p:style>
         <p:txBody>
-          <a:bodyPr wrap="none" rtlCol="0" anchor="ctr"/>
+          <a:bodyPr rtlCol="0" anchor="ctr" wrap="none"/>
           <a:lstStyle/>
           <a:p>
             <a:pPr algn="ctr">
@@ -19680,7 +19456,6 @@
           <a:lstStyle/>
           <a:p>
             <a:pPr algn="ctr"/>
-            <a:endParaRPr/>
           </a:p>
         </p:txBody>
       </p:sp>
@@ -19722,7 +19497,7 @@
           </a:fontRef>
         </p:style>
         <p:txBody>
-          <a:bodyPr wrap="none" rtlCol="0" anchor="ctr"/>
+          <a:bodyPr rtlCol="0" anchor="ctr" wrap="none"/>
           <a:lstStyle/>
           <a:p>
             <a:pPr algn="ctr">
@@ -19775,7 +19550,7 @@
           </a:fontRef>
         </p:style>
         <p:txBody>
-          <a:bodyPr wrap="none" rtlCol="0" anchor="ctr"/>
+          <a:bodyPr rtlCol="0" anchor="ctr" wrap="none"/>
           <a:lstStyle/>
           <a:p>
             <a:pPr algn="ctr">
@@ -19835,7 +19610,7 @@
               </a:defRPr>
             </a:pPr>
             <a:r>
-              <a:t>Autonomous Remediation</a:t>
+              <a:t>Remediation Recommendation</a:t>
             </a:r>
           </a:p>
         </p:txBody>
@@ -19877,7 +19652,7 @@
               </a:defRPr>
             </a:pPr>
             <a:r>
-              <a:t>The system verifies the fix in a digital twin sandbox via Nash Equilibrium coordination, then deploys it to the live network.</a:t>
+              <a:t>The system selects a candidate via Nash Equilibrium coordination and produces a recommended command. In the prototype it is NOT auto-deployed.</a:t>
             </a:r>
           </a:p>
         </p:txBody>
@@ -19924,7 +19699,6 @@
           <a:lstStyle/>
           <a:p>
             <a:pPr algn="ctr"/>
-            <a:endParaRPr/>
           </a:p>
         </p:txBody>
       </p:sp>
@@ -19965,7 +19739,7 @@
               </a:defRPr>
             </a:pPr>
             <a:r>
-              <a:t>OUR INNOVATION:   AI Predicts  →  AI Generates Futures  →  AI Tests &amp; Fixes Autonomously   •  CLOSED-LOOP  •  &lt; 10 SECONDS</a:t>
+              <a:t>OUR APPROACH:   AI Detects  →  AI Generates Counterfactual Futures  →  AI Recommends a Remediation   •  DecisioN Compute ms  •  Not Auto-Deployed</a:t>
             </a:r>
           </a:p>
         </p:txBody>
@@ -19979,7 +19753,7 @@
 </file>
 
 <file path=ppt/slides/slide5.xml><?xml version="1.0" encoding="utf-8"?>
-<p:sld xmlns:a="http://schemas.openxmlformats.org/drawingml/2006/main" xmlns:r="http://schemas.openxmlformats.org/officeDocument/2006/relationships" xmlns:p="http://schemas.openxmlformats.org/presentationml/2006/main">
+<p:sld xmlns:a="http://schemas.openxmlformats.org/drawingml/2006/main" xmlns:p="http://schemas.openxmlformats.org/presentationml/2006/main" xmlns:r="http://schemas.openxmlformats.org/officeDocument/2006/relationships">
   <p:cSld>
     <p:bg>
       <p:bgPr>
@@ -19995,14 +19769,7 @@
         <p:cNvGrpSpPr/>
         <p:nvPr/>
       </p:nvGrpSpPr>
-      <p:grpSpPr>
-        <a:xfrm>
-          <a:off x="0" y="0"/>
-          <a:ext cx="0" cy="0"/>
-          <a:chOff x="0" y="0"/>
-          <a:chExt cx="0" cy="0"/>
-        </a:xfrm>
-      </p:grpSpPr>
+      <p:grpSpPr/>
       <p:sp>
         <p:nvSpPr>
           <p:cNvPr id="2" name="Rectangle 1"/>
@@ -20043,7 +19810,6 @@
           <a:lstStyle/>
           <a:p>
             <a:pPr algn="ctr"/>
-            <a:endParaRPr/>
           </a:p>
         </p:txBody>
       </p:sp>
@@ -20169,7 +19935,7 @@
           </a:fontRef>
         </p:style>
         <p:txBody>
-          <a:bodyPr wrap="none" rtlCol="0" anchor="ctr"/>
+          <a:bodyPr rtlCol="0" anchor="ctr" wrap="none"/>
           <a:lstStyle/>
           <a:p>
             <a:pPr algn="ctr">
@@ -20268,7 +20034,6 @@
           <a:lstStyle/>
           <a:p>
             <a:pPr algn="ctr"/>
-            <a:endParaRPr/>
           </a:p>
         </p:txBody>
       </p:sp>
@@ -20309,7 +20074,7 @@
               </a:defRPr>
             </a:pPr>
             <a:r>
-              <a:t>From live telemetry ingestion to autonomous execution — a closed loop that runs in seconds.</a:t>
+              <a:t>From live telemetry ingestion to remediation recommendation — a closed pipeline that runs in milliseconds of decision compute (not deployment).</a:t>
             </a:r>
           </a:p>
         </p:txBody>
@@ -20356,7 +20121,6 @@
           <a:lstStyle/>
           <a:p>
             <a:pPr algn="ctr"/>
-            <a:endParaRPr/>
           </a:p>
         </p:txBody>
       </p:sp>
@@ -20396,7 +20160,7 @@
           </a:fontRef>
         </p:style>
         <p:txBody>
-          <a:bodyPr wrap="none" rtlCol="0" anchor="ctr"/>
+          <a:bodyPr rtlCol="0" anchor="ctr" wrap="none"/>
           <a:lstStyle/>
           <a:p>
             <a:pPr algn="ctr">
@@ -20499,7 +20263,7 @@
           </a:fontRef>
         </p:style>
         <p:txBody>
-          <a:bodyPr wrap="none" rtlCol="0" anchor="ctr"/>
+          <a:bodyPr rtlCol="0" anchor="ctr" wrap="none"/>
           <a:lstStyle/>
           <a:p>
             <a:pPr algn="ctr">
@@ -20511,7 +20275,7 @@
               </a:defRPr>
             </a:pPr>
             <a:r>
-              <a:t>~1s</a:t>
+              <a:t>live</a:t>
             </a:r>
           </a:p>
         </p:txBody>
@@ -20606,7 +20370,6 @@
           <a:lstStyle/>
           <a:p>
             <a:pPr algn="ctr"/>
-            <a:endParaRPr/>
           </a:p>
         </p:txBody>
       </p:sp>
@@ -20652,7 +20415,6 @@
           <a:lstStyle/>
           <a:p>
             <a:pPr algn="ctr"/>
-            <a:endParaRPr/>
           </a:p>
         </p:txBody>
       </p:sp>
@@ -20692,7 +20454,7 @@
           </a:fontRef>
         </p:style>
         <p:txBody>
-          <a:bodyPr wrap="none" rtlCol="0" anchor="ctr"/>
+          <a:bodyPr rtlCol="0" anchor="ctr" wrap="none"/>
           <a:lstStyle/>
           <a:p>
             <a:pPr algn="ctr">
@@ -20795,7 +20557,7 @@
           </a:fontRef>
         </p:style>
         <p:txBody>
-          <a:bodyPr wrap="none" rtlCol="0" anchor="ctr"/>
+          <a:bodyPr rtlCol="0" anchor="ctr" wrap="none"/>
           <a:lstStyle/>
           <a:p>
             <a:pPr algn="ctr">
@@ -20807,7 +20569,7 @@
               </a:defRPr>
             </a:pPr>
             <a:r>
-              <a:t>~2s</a:t>
+              <a:t>ms</a:t>
             </a:r>
           </a:p>
         </p:txBody>
@@ -20906,7 +20668,6 @@
           <a:lstStyle/>
           <a:p>
             <a:pPr algn="ctr"/>
-            <a:endParaRPr/>
           </a:p>
         </p:txBody>
       </p:sp>
@@ -20952,7 +20713,6 @@
           <a:lstStyle/>
           <a:p>
             <a:pPr algn="ctr"/>
-            <a:endParaRPr/>
           </a:p>
         </p:txBody>
       </p:sp>
@@ -20992,7 +20752,7 @@
           </a:fontRef>
         </p:style>
         <p:txBody>
-          <a:bodyPr wrap="none" rtlCol="0" anchor="ctr"/>
+          <a:bodyPr rtlCol="0" anchor="ctr" wrap="none"/>
           <a:lstStyle/>
           <a:p>
             <a:pPr algn="ctr">
@@ -21052,7 +20812,7 @@
               </a:defRPr>
             </a:pPr>
             <a:r>
-              <a:t>SIMULATE</a:t>
+              <a:t>SELECT</a:t>
             </a:r>
           </a:p>
         </p:txBody>
@@ -21095,7 +20855,7 @@
           </a:fontRef>
         </p:style>
         <p:txBody>
-          <a:bodyPr wrap="none" rtlCol="0" anchor="ctr"/>
+          <a:bodyPr rtlCol="0" anchor="ctr" wrap="none"/>
           <a:lstStyle/>
           <a:p>
             <a:pPr algn="ctr">
@@ -21107,7 +20867,7 @@
               </a:defRPr>
             </a:pPr>
             <a:r>
-              <a:t>~2s</a:t>
+              <a:t>ms</a:t>
             </a:r>
           </a:p>
         </p:txBody>
@@ -21153,15 +20913,15 @@
             </a:r>
             <a:br/>
             <a:r>
-              <a:t>Shapley + Causal Inf.</a:t>
+              <a:t>Shapley</a:t>
             </a:r>
             <a:br/>
             <a:r>
-              <a:t>Agent 2: Test in DT</a:t>
+              <a:t>Agent 2: SPE + VCG</a:t>
             </a:r>
             <a:br/>
             <a:r>
-              <a:t>Agent 3: Write fix script</a:t>
+              <a:t>Agent 3: pick via projection</a:t>
             </a:r>
           </a:p>
         </p:txBody>
@@ -21206,7 +20966,6 @@
           <a:lstStyle/>
           <a:p>
             <a:pPr algn="ctr"/>
-            <a:endParaRPr/>
           </a:p>
         </p:txBody>
       </p:sp>
@@ -21252,7 +21011,6 @@
           <a:lstStyle/>
           <a:p>
             <a:pPr algn="ctr"/>
-            <a:endParaRPr/>
           </a:p>
         </p:txBody>
       </p:sp>
@@ -21292,7 +21050,7 @@
           </a:fontRef>
         </p:style>
         <p:txBody>
-          <a:bodyPr wrap="none" rtlCol="0" anchor="ctr"/>
+          <a:bodyPr rtlCol="0" anchor="ctr" wrap="none"/>
           <a:lstStyle/>
           <a:p>
             <a:pPr algn="ctr">
@@ -21352,7 +21110,7 @@
               </a:defRPr>
             </a:pPr>
             <a:r>
-              <a:t>DEPLOY</a:t>
+              <a:t>RECOMMEND</a:t>
             </a:r>
           </a:p>
         </p:txBody>
@@ -21395,7 +21153,7 @@
           </a:fontRef>
         </p:style>
         <p:txBody>
-          <a:bodyPr wrap="none" rtlCol="0" anchor="ctr"/>
+          <a:bodyPr rtlCol="0" anchor="ctr" wrap="none"/>
           <a:lstStyle/>
           <a:p>
             <a:pPr algn="ctr">
@@ -21407,7 +21165,7 @@
               </a:defRPr>
             </a:pPr>
             <a:r>
-              <a:t>~5s</a:t>
+              <a:t>only</a:t>
             </a:r>
           </a:p>
         </p:txBody>
@@ -21449,19 +21207,15 @@
               </a:defRPr>
             </a:pPr>
             <a:r>
-              <a:t>NETCONF/YANG push</a:t>
+              <a:t>Generates recommended</a:t>
             </a:r>
             <a:br/>
             <a:r>
-              <a:t>verified config</a:t>
+              <a:t>command; NOT auto-deployed</a:t>
             </a:r>
             <a:br/>
             <a:r>
-              <a:t>+ rollback engine</a:t>
-            </a:r>
-            <a:br/>
-            <a:r>
-              <a:t>+ full audit trail</a:t>
+              <a:t>in the prototype</a:t>
             </a:r>
           </a:p>
         </p:txBody>
@@ -21508,7 +21262,6 @@
           <a:lstStyle/>
           <a:p>
             <a:pPr algn="ctr"/>
-            <a:endParaRPr/>
           </a:p>
         </p:txBody>
       </p:sp>
@@ -21549,7 +21302,7 @@
               </a:defRPr>
             </a:pPr>
             <a:r>
-              <a:t>TOTAL END-TO-END LATENCY:  &lt; 10 SECONDS   │  DETECT ~1s  →  GENERATE ~2s  →  SIMULATE ~2s  →  DEPLOY ~5s</a:t>
+              <a:t>IN-PROCESS DECISION COMPUTE:  milliseconds   │  Excludes LLM round-trip and real device deployment; end-to-end MTTR not claimed</a:t>
             </a:r>
           </a:p>
         </p:txBody>
@@ -21563,7 +21316,7 @@
 </file>
 
 <file path=ppt/slides/slide6.xml><?xml version="1.0" encoding="utf-8"?>
-<p:sld xmlns:a="http://schemas.openxmlformats.org/drawingml/2006/main" xmlns:r="http://schemas.openxmlformats.org/officeDocument/2006/relationships" xmlns:p="http://schemas.openxmlformats.org/presentationml/2006/main">
+<p:sld xmlns:a="http://schemas.openxmlformats.org/drawingml/2006/main" xmlns:p="http://schemas.openxmlformats.org/presentationml/2006/main" xmlns:r="http://schemas.openxmlformats.org/officeDocument/2006/relationships">
   <p:cSld>
     <p:bg>
       <p:bgPr>
@@ -21579,14 +21332,7 @@
         <p:cNvGrpSpPr/>
         <p:nvPr/>
       </p:nvGrpSpPr>
-      <p:grpSpPr>
-        <a:xfrm>
-          <a:off x="0" y="0"/>
-          <a:ext cx="0" cy="0"/>
-          <a:chOff x="0" y="0"/>
-          <a:chExt cx="0" cy="0"/>
-        </a:xfrm>
-      </p:grpSpPr>
+      <p:grpSpPr/>
       <p:sp>
         <p:nvSpPr>
           <p:cNvPr id="2" name="Rectangle 1"/>
@@ -21627,7 +21373,6 @@
           <a:lstStyle/>
           <a:p>
             <a:pPr algn="ctr"/>
-            <a:endParaRPr/>
           </a:p>
         </p:txBody>
       </p:sp>
@@ -21753,7 +21498,7 @@
           </a:fontRef>
         </p:style>
         <p:txBody>
-          <a:bodyPr wrap="none" rtlCol="0" anchor="ctr"/>
+          <a:bodyPr rtlCol="0" anchor="ctr" wrap="none"/>
           <a:lstStyle/>
           <a:p>
             <a:pPr algn="ctr">
@@ -21808,7 +21553,7 @@
           </a:fontRef>
         </p:style>
         <p:txBody>
-          <a:bodyPr wrap="none" rtlCol="0" anchor="ctr"/>
+          <a:bodyPr rtlCol="0" anchor="ctr" wrap="none"/>
           <a:lstStyle/>
           <a:p>
             <a:pPr algn="ctr">
@@ -21907,7 +21652,6 @@
           <a:lstStyle/>
           <a:p>
             <a:pPr algn="ctr"/>
-            <a:endParaRPr/>
           </a:p>
         </p:txBody>
       </p:sp>
@@ -21953,7 +21697,6 @@
           <a:lstStyle/>
           <a:p>
             <a:pPr algn="ctr"/>
-            <a:endParaRPr/>
           </a:p>
         </p:txBody>
       </p:sp>
@@ -21993,7 +21736,7 @@
           </a:fontRef>
         </p:style>
         <p:txBody>
-          <a:bodyPr wrap="none" rtlCol="0" anchor="ctr"/>
+          <a:bodyPr rtlCol="0" anchor="ctr" wrap="none"/>
           <a:lstStyle/>
           <a:p>
             <a:pPr algn="ctr">
@@ -22196,7 +21939,6 @@
           <a:lstStyle/>
           <a:p>
             <a:pPr algn="ctr"/>
-            <a:endParaRPr/>
           </a:p>
         </p:txBody>
       </p:sp>
@@ -22236,7 +21978,7 @@
           </a:fontRef>
         </p:style>
         <p:txBody>
-          <a:bodyPr wrap="none" rtlCol="0" anchor="ctr"/>
+          <a:bodyPr rtlCol="0" anchor="ctr" wrap="none"/>
           <a:lstStyle/>
           <a:p>
             <a:pPr algn="ctr">
@@ -22439,7 +22181,6 @@
           <a:lstStyle/>
           <a:p>
             <a:pPr algn="ctr"/>
-            <a:endParaRPr/>
           </a:p>
         </p:txBody>
       </p:sp>
@@ -22479,7 +22220,7 @@
           </a:fontRef>
         </p:style>
         <p:txBody>
-          <a:bodyPr wrap="none" rtlCol="0" anchor="ctr"/>
+          <a:bodyPr rtlCol="0" anchor="ctr" wrap="none"/>
           <a:lstStyle/>
           <a:p>
             <a:pPr algn="ctr">
@@ -22582,7 +22323,7 @@
           </a:fontRef>
         </p:style>
         <p:txBody>
-          <a:bodyPr wrap="none" rtlCol="0" anchor="ctr"/>
+          <a:bodyPr rtlCol="0" anchor="ctr" wrap="none"/>
           <a:lstStyle/>
           <a:p>
             <a:pPr algn="ctr">
@@ -22683,7 +22424,7 @@
           </a:fontRef>
         </p:style>
         <p:txBody>
-          <a:bodyPr wrap="none" rtlCol="0" anchor="ctr"/>
+          <a:bodyPr rtlCol="0" anchor="ctr" wrap="none"/>
           <a:lstStyle/>
           <a:p>
             <a:pPr algn="ctr">
@@ -22695,7 +22436,7 @@
               </a:defRPr>
             </a:pPr>
             <a:r>
-              <a:t>Agent 2 — Simulator</a:t>
+              <a:t>Agent 2 — Projector</a:t>
             </a:r>
           </a:p>
         </p:txBody>
@@ -22737,11 +22478,11 @@
               </a:defRPr>
             </a:pPr>
             <a:r>
-              <a:t>Tests candidate fixes in</a:t>
+              <a:t>Runs counterfactual diffusion</a:t>
             </a:r>
             <a:br/>
             <a:r>
-              <a:t>digital twin sandbox</a:t>
+              <a:t>to project 'what-if' outcomes</a:t>
             </a:r>
           </a:p>
         </p:txBody>
@@ -22784,7 +22525,7 @@
           </a:fontRef>
         </p:style>
         <p:txBody>
-          <a:bodyPr wrap="none" rtlCol="0" anchor="ctr"/>
+          <a:bodyPr rtlCol="0" anchor="ctr" wrap="none"/>
           <a:lstStyle/>
           <a:p>
             <a:pPr algn="ctr">
@@ -22796,7 +22537,7 @@
               </a:defRPr>
             </a:pPr>
             <a:r>
-              <a:t>Agent 3 — Executor</a:t>
+              <a:t>Agent 3 — Advisor</a:t>
             </a:r>
           </a:p>
         </p:txBody>
@@ -22838,11 +22579,11 @@
               </a:defRPr>
             </a:pPr>
             <a:r>
-              <a:t>Generates NETCONF/YANG</a:t>
+              <a:t>Generates recommended</a:t>
             </a:r>
             <a:br/>
             <a:r>
-              <a:t>configuration scripts</a:t>
+              <a:t>NETCONF/YANG config draft</a:t>
             </a:r>
           </a:p>
         </p:txBody>
@@ -22856,7 +22597,7 @@
 </file>
 
 <file path=ppt/slides/slide7.xml><?xml version="1.0" encoding="utf-8"?>
-<p:sld xmlns:a="http://schemas.openxmlformats.org/drawingml/2006/main" xmlns:r="http://schemas.openxmlformats.org/officeDocument/2006/relationships" xmlns:p="http://schemas.openxmlformats.org/presentationml/2006/main">
+<p:sld xmlns:a="http://schemas.openxmlformats.org/drawingml/2006/main" xmlns:p="http://schemas.openxmlformats.org/presentationml/2006/main" xmlns:r="http://schemas.openxmlformats.org/officeDocument/2006/relationships">
   <p:cSld>
     <p:bg>
       <p:bgPr>
@@ -22872,14 +22613,7 @@
         <p:cNvGrpSpPr/>
         <p:nvPr/>
       </p:nvGrpSpPr>
-      <p:grpSpPr>
-        <a:xfrm>
-          <a:off x="0" y="0"/>
-          <a:ext cx="0" cy="0"/>
-          <a:chOff x="0" y="0"/>
-          <a:chExt cx="0" cy="0"/>
-        </a:xfrm>
-      </p:grpSpPr>
+      <p:grpSpPr/>
       <p:sp>
         <p:nvSpPr>
           <p:cNvPr id="2" name="Rectangle 1"/>
@@ -22920,7 +22654,6 @@
           <a:lstStyle/>
           <a:p>
             <a:pPr algn="ctr"/>
-            <a:endParaRPr/>
           </a:p>
         </p:txBody>
       </p:sp>
@@ -23046,7 +22779,7 @@
           </a:fontRef>
         </p:style>
         <p:txBody>
-          <a:bodyPr wrap="none" rtlCol="0" anchor="ctr"/>
+          <a:bodyPr rtlCol="0" anchor="ctr" wrap="none"/>
           <a:lstStyle/>
           <a:p>
             <a:pPr algn="ctr">
@@ -23101,7 +22834,7 @@
           </a:fontRef>
         </p:style>
         <p:txBody>
-          <a:bodyPr wrap="none" rtlCol="0" anchor="ctr"/>
+          <a:bodyPr rtlCol="0" anchor="ctr" wrap="none"/>
           <a:lstStyle/>
           <a:p>
             <a:pPr algn="ctr">
@@ -23200,7 +22933,6 @@
           <a:lstStyle/>
           <a:p>
             <a:pPr algn="ctr"/>
-            <a:endParaRPr/>
           </a:p>
         </p:txBody>
       </p:sp>
@@ -23288,7 +23020,6 @@
           <a:lstStyle/>
           <a:p>
             <a:pPr algn="ctr"/>
-            <a:endParaRPr/>
           </a:p>
         </p:txBody>
       </p:sp>
@@ -23328,7 +23059,7 @@
           </a:fontRef>
         </p:style>
         <p:txBody>
-          <a:bodyPr wrap="none" rtlCol="0" anchor="ctr"/>
+          <a:bodyPr rtlCol="0" anchor="ctr" wrap="none"/>
           <a:lstStyle/>
           <a:p>
             <a:pPr algn="ctr">
@@ -23431,7 +23162,7 @@
           </a:fontRef>
         </p:style>
         <p:txBody>
-          <a:bodyPr wrap="none" rtlCol="0" anchor="ctr"/>
+          <a:bodyPr rtlCol="0" anchor="ctr" wrap="none"/>
           <a:lstStyle/>
           <a:p>
             <a:pPr algn="ctr">
@@ -23574,7 +23305,6 @@
           <a:lstStyle/>
           <a:p>
             <a:pPr algn="ctr"/>
-            <a:endParaRPr/>
           </a:p>
         </p:txBody>
       </p:sp>
@@ -23614,7 +23344,7 @@
           </a:fontRef>
         </p:style>
         <p:txBody>
-          <a:bodyPr wrap="none" rtlCol="0" anchor="ctr"/>
+          <a:bodyPr rtlCol="0" anchor="ctr" wrap="none"/>
           <a:lstStyle/>
           <a:p>
             <a:pPr algn="ctr">
@@ -23717,7 +23447,7 @@
           </a:fontRef>
         </p:style>
         <p:txBody>
-          <a:bodyPr wrap="none" rtlCol="0" anchor="ctr"/>
+          <a:bodyPr rtlCol="0" anchor="ctr" wrap="none"/>
           <a:lstStyle/>
           <a:p>
             <a:pPr algn="ctr">
@@ -23860,7 +23590,6 @@
           <a:lstStyle/>
           <a:p>
             <a:pPr algn="ctr"/>
-            <a:endParaRPr/>
           </a:p>
         </p:txBody>
       </p:sp>
@@ -23900,7 +23629,7 @@
           </a:fontRef>
         </p:style>
         <p:txBody>
-          <a:bodyPr wrap="none" rtlCol="0" anchor="ctr"/>
+          <a:bodyPr rtlCol="0" anchor="ctr" wrap="none"/>
           <a:lstStyle/>
           <a:p>
             <a:pPr algn="ctr">
@@ -24003,7 +23732,7 @@
           </a:fontRef>
         </p:style>
         <p:txBody>
-          <a:bodyPr wrap="none" rtlCol="0" anchor="ctr"/>
+          <a:bodyPr rtlCol="0" anchor="ctr" wrap="none"/>
           <a:lstStyle/>
           <a:p>
             <a:pPr algn="ctr">
@@ -24146,7 +23875,6 @@
           <a:lstStyle/>
           <a:p>
             <a:pPr algn="ctr"/>
-            <a:endParaRPr/>
           </a:p>
         </p:txBody>
       </p:sp>
@@ -24186,7 +23914,7 @@
           </a:fontRef>
         </p:style>
         <p:txBody>
-          <a:bodyPr wrap="none" rtlCol="0" anchor="ctr"/>
+          <a:bodyPr rtlCol="0" anchor="ctr" wrap="none"/>
           <a:lstStyle/>
           <a:p>
             <a:pPr algn="ctr">
@@ -24289,7 +24017,7 @@
           </a:fontRef>
         </p:style>
         <p:txBody>
-          <a:bodyPr wrap="none" rtlCol="0" anchor="ctr"/>
+          <a:bodyPr rtlCol="0" anchor="ctr" wrap="none"/>
           <a:lstStyle/>
           <a:p>
             <a:pPr algn="ctr">
@@ -24399,7 +24127,7 @@
 </file>
 
 <file path=ppt/slides/slide8.xml><?xml version="1.0" encoding="utf-8"?>
-<p:sld xmlns:a="http://schemas.openxmlformats.org/drawingml/2006/main" xmlns:r="http://schemas.openxmlformats.org/officeDocument/2006/relationships" xmlns:p="http://schemas.openxmlformats.org/presentationml/2006/main">
+<p:sld xmlns:a="http://schemas.openxmlformats.org/drawingml/2006/main" xmlns:p="http://schemas.openxmlformats.org/presentationml/2006/main" xmlns:r="http://schemas.openxmlformats.org/officeDocument/2006/relationships">
   <p:cSld>
     <p:bg>
       <p:bgPr>
@@ -24415,14 +24143,7 @@
         <p:cNvGrpSpPr/>
         <p:nvPr/>
       </p:nvGrpSpPr>
-      <p:grpSpPr>
-        <a:xfrm>
-          <a:off x="0" y="0"/>
-          <a:ext cx="0" cy="0"/>
-          <a:chOff x="0" y="0"/>
-          <a:chExt cx="0" cy="0"/>
-        </a:xfrm>
-      </p:grpSpPr>
+      <p:grpSpPr/>
       <p:sp>
         <p:nvSpPr>
           <p:cNvPr id="2" name="Rectangle 1"/>
@@ -24463,7 +24184,6 @@
           <a:lstStyle/>
           <a:p>
             <a:pPr algn="ctr"/>
-            <a:endParaRPr/>
           </a:p>
         </p:txBody>
       </p:sp>
@@ -24589,7 +24309,7 @@
           </a:fontRef>
         </p:style>
         <p:txBody>
-          <a:bodyPr wrap="none" rtlCol="0" anchor="ctr"/>
+          <a:bodyPr rtlCol="0" anchor="ctr" wrap="none"/>
           <a:lstStyle/>
           <a:p>
             <a:pPr algn="ctr">
@@ -24688,7 +24408,6 @@
           <a:lstStyle/>
           <a:p>
             <a:pPr algn="ctr"/>
-            <a:endParaRPr/>
           </a:p>
         </p:txBody>
       </p:sp>
@@ -24734,7 +24453,6 @@
           <a:lstStyle/>
           <a:p>
             <a:pPr algn="ctr"/>
-            <a:endParaRPr/>
           </a:p>
         </p:txBody>
       </p:sp>
@@ -24774,7 +24492,7 @@
           </a:fontRef>
         </p:style>
         <p:txBody>
-          <a:bodyPr wrap="none" rtlCol="0" anchor="ctr"/>
+          <a:bodyPr rtlCol="0" anchor="ctr" wrap="none"/>
           <a:lstStyle/>
           <a:p>
             <a:pPr algn="ctr">
@@ -24834,7 +24552,7 @@
               </a:defRPr>
             </a:pPr>
             <a:r>
-              <a:t>Sub-Second MTTR</a:t>
+              <a:t>Fast Decision Compute</a:t>
             </a:r>
           </a:p>
         </p:txBody>
@@ -24876,7 +24594,7 @@
               </a:defRPr>
             </a:pPr>
             <a:r>
-              <a:t>MTTR from hours/days to &lt; 10 seconds</a:t>
+              <a:t>In-process compute is sub-millisecond (excludes LLM &amp; deployment)</a:t>
             </a:r>
           </a:p>
         </p:txBody>
@@ -24923,7 +24641,6 @@
           <a:lstStyle/>
           <a:p>
             <a:pPr algn="ctr"/>
-            <a:endParaRPr/>
           </a:p>
         </p:txBody>
       </p:sp>
@@ -24963,7 +24680,7 @@
           </a:fontRef>
         </p:style>
         <p:txBody>
-          <a:bodyPr wrap="none" rtlCol="0" anchor="ctr"/>
+          <a:bodyPr rtlCol="0" anchor="ctr" wrap="none"/>
           <a:lstStyle/>
           <a:p>
             <a:pPr algn="ctr">
@@ -25023,7 +24740,7 @@
               </a:defRPr>
             </a:pPr>
             <a:r>
-              <a:t>Zero-Risk Fixes</a:t>
+              <a:t>Projection-based Selection</a:t>
             </a:r>
           </a:p>
         </p:txBody>
@@ -25065,7 +24782,7 @@
               </a:defRPr>
             </a:pPr>
             <a:r>
-              <a:t>Validated in digital twin before live deploy</a:t>
+              <a:t>Remediation chosen from projected scenarios; not auto-deployed</a:t>
             </a:r>
           </a:p>
         </p:txBody>
@@ -25112,7 +24829,6 @@
           <a:lstStyle/>
           <a:p>
             <a:pPr algn="ctr"/>
-            <a:endParaRPr/>
           </a:p>
         </p:txBody>
       </p:sp>
@@ -25152,7 +24868,7 @@
           </a:fontRef>
         </p:style>
         <p:txBody>
-          <a:bodyPr wrap="none" rtlCol="0" anchor="ctr"/>
+          <a:bodyPr rtlCol="0" anchor="ctr" wrap="none"/>
           <a:lstStyle/>
           <a:p>
             <a:pPr algn="ctr">
@@ -25212,7 +24928,7 @@
               </a:defRPr>
             </a:pPr>
             <a:r>
-              <a:t>40% OPEX Cut</a:t>
+              <a:t>Potential OPEX Benefit</a:t>
             </a:r>
           </a:p>
         </p:txBody>
@@ -25254,7 +24970,7 @@
               </a:defRPr>
             </a:pPr>
             <a:r>
-              <a:t>Eliminates unnecessary truck rolls</a:t>
+              <a:t>May avoid truck-rolls (not yet measured)</a:t>
             </a:r>
           </a:p>
         </p:txBody>
@@ -25301,7 +25017,6 @@
           <a:lstStyle/>
           <a:p>
             <a:pPr algn="ctr"/>
-            <a:endParaRPr/>
           </a:p>
         </p:txBody>
       </p:sp>
@@ -25341,7 +25056,7 @@
           </a:fontRef>
         </p:style>
         <p:txBody>
-          <a:bodyPr wrap="none" rtlCol="0" anchor="ctr"/>
+          <a:bodyPr rtlCol="0" anchor="ctr" wrap="none"/>
           <a:lstStyle/>
           <a:p>
             <a:pPr algn="ctr">
@@ -25401,7 +25116,7 @@
               </a:defRPr>
             </a:pPr>
             <a:r>
-              <a:t>Explainable RCA</a:t>
+              <a:t>Explainable Attribution</a:t>
             </a:r>
           </a:p>
         </p:txBody>
@@ -25490,7 +25205,6 @@
           <a:lstStyle/>
           <a:p>
             <a:pPr algn="ctr"/>
-            <a:endParaRPr/>
           </a:p>
         </p:txBody>
       </p:sp>
@@ -25530,7 +25244,7 @@
           </a:fontRef>
         </p:style>
         <p:txBody>
-          <a:bodyPr wrap="none" rtlCol="0" anchor="ctr"/>
+          <a:bodyPr rtlCol="0" anchor="ctr" wrap="none"/>
           <a:lstStyle/>
           <a:p>
             <a:pPr algn="ctr">
@@ -25679,7 +25393,6 @@
           <a:lstStyle/>
           <a:p>
             <a:pPr algn="ctr"/>
-            <a:endParaRPr/>
           </a:p>
         </p:txBody>
       </p:sp>
@@ -25719,7 +25432,7 @@
           </a:fontRef>
         </p:style>
         <p:txBody>
-          <a:bodyPr wrap="none" rtlCol="0" anchor="ctr"/>
+          <a:bodyPr rtlCol="0" anchor="ctr" wrap="none"/>
           <a:lstStyle/>
           <a:p>
             <a:pPr algn="ctr">
@@ -25868,7 +25581,6 @@
           <a:lstStyle/>
           <a:p>
             <a:pPr algn="ctr"/>
-            <a:endParaRPr/>
           </a:p>
         </p:txBody>
       </p:sp>
@@ -25908,7 +25620,7 @@
           </a:fontRef>
         </p:style>
         <p:txBody>
-          <a:bodyPr wrap="none" rtlCol="0" anchor="ctr"/>
+          <a:bodyPr rtlCol="0" anchor="ctr" wrap="none"/>
           <a:lstStyle/>
           <a:p>
             <a:pPr algn="ctr">
@@ -26057,7 +25769,6 @@
           <a:lstStyle/>
           <a:p>
             <a:pPr algn="ctr"/>
-            <a:endParaRPr/>
           </a:p>
         </p:txBody>
       </p:sp>
@@ -26097,7 +25808,7 @@
           </a:fontRef>
         </p:style>
         <p:txBody>
-          <a:bodyPr wrap="none" rtlCol="0" anchor="ctr"/>
+          <a:bodyPr rtlCol="0" anchor="ctr" wrap="none"/>
           <a:lstStyle/>
           <a:p>
             <a:pPr algn="ctr">
@@ -26246,7 +25957,6 @@
           <a:lstStyle/>
           <a:p>
             <a:pPr algn="ctr"/>
-            <a:endParaRPr/>
           </a:p>
         </p:txBody>
       </p:sp>
@@ -26286,7 +25996,7 @@
           </a:fontRef>
         </p:style>
         <p:txBody>
-          <a:bodyPr wrap="none" rtlCol="0" anchor="ctr"/>
+          <a:bodyPr rtlCol="0" anchor="ctr" wrap="none"/>
           <a:lstStyle/>
           <a:p>
             <a:pPr algn="ctr">
@@ -26435,7 +26145,6 @@
           <a:lstStyle/>
           <a:p>
             <a:pPr algn="ctr"/>
-            <a:endParaRPr/>
           </a:p>
         </p:txBody>
       </p:sp>
@@ -26475,7 +26184,7 @@
           </a:fontRef>
         </p:style>
         <p:txBody>
-          <a:bodyPr wrap="none" rtlCol="0" anchor="ctr"/>
+          <a:bodyPr rtlCol="0" anchor="ctr" wrap="none"/>
           <a:lstStyle/>
           <a:p>
             <a:pPr algn="ctr">
@@ -26591,7 +26300,7 @@
 </file>
 
 <file path=ppt/slides/slide9.xml><?xml version="1.0" encoding="utf-8"?>
-<p:sld xmlns:a="http://schemas.openxmlformats.org/drawingml/2006/main" xmlns:r="http://schemas.openxmlformats.org/officeDocument/2006/relationships" xmlns:p="http://schemas.openxmlformats.org/presentationml/2006/main">
+<p:sld xmlns:a="http://schemas.openxmlformats.org/drawingml/2006/main" xmlns:p="http://schemas.openxmlformats.org/presentationml/2006/main" xmlns:r="http://schemas.openxmlformats.org/officeDocument/2006/relationships">
   <p:cSld>
     <p:bg>
       <p:bgPr>
@@ -26607,14 +26316,7 @@
         <p:cNvGrpSpPr/>
         <p:nvPr/>
       </p:nvGrpSpPr>
-      <p:grpSpPr>
-        <a:xfrm>
-          <a:off x="0" y="0"/>
-          <a:ext cx="0" cy="0"/>
-          <a:chOff x="0" y="0"/>
-          <a:chExt cx="0" cy="0"/>
-        </a:xfrm>
-      </p:grpSpPr>
+      <p:grpSpPr/>
       <p:sp>
         <p:nvSpPr>
           <p:cNvPr id="2" name="Rectangle 1"/>
@@ -26655,7 +26357,6 @@
           <a:lstStyle/>
           <a:p>
             <a:pPr algn="ctr"/>
-            <a:endParaRPr/>
           </a:p>
         </p:txBody>
       </p:sp>
@@ -26781,7 +26482,7 @@
           </a:fontRef>
         </p:style>
         <p:txBody>
-          <a:bodyPr wrap="none" rtlCol="0" anchor="ctr"/>
+          <a:bodyPr rtlCol="0" anchor="ctr" wrap="none"/>
           <a:lstStyle/>
           <a:p>
             <a:pPr algn="ctr">
@@ -26880,7 +26581,6 @@
           <a:lstStyle/>
           <a:p>
             <a:pPr algn="ctr"/>
-            <a:endParaRPr/>
           </a:p>
         </p:txBody>
       </p:sp>
@@ -26926,7 +26626,6 @@
           <a:lstStyle/>
           <a:p>
             <a:pPr algn="ctr"/>
-            <a:endParaRPr/>
           </a:p>
         </p:txBody>
       </p:sp>
@@ -26966,7 +26665,7 @@
           </a:fontRef>
         </p:style>
         <p:txBody>
-          <a:bodyPr wrap="none" rtlCol="0" anchor="ctr"/>
+          <a:bodyPr rtlCol="0" anchor="ctr" wrap="none"/>
           <a:lstStyle/>
           <a:p>
             <a:pPr algn="ctr">
@@ -27115,7 +26814,6 @@
           <a:lstStyle/>
           <a:p>
             <a:pPr algn="ctr"/>
-            <a:endParaRPr/>
           </a:p>
         </p:txBody>
       </p:sp>
@@ -27245,7 +26943,6 @@
           <a:lstStyle/>
           <a:p>
             <a:pPr algn="ctr"/>
-            <a:endParaRPr/>
           </a:p>
         </p:txBody>
       </p:sp>
@@ -27285,7 +26982,7 @@
           </a:fontRef>
         </p:style>
         <p:txBody>
-          <a:bodyPr wrap="none" rtlCol="0" anchor="ctr"/>
+          <a:bodyPr rtlCol="0" anchor="ctr" wrap="none"/>
           <a:lstStyle/>
           <a:p>
             <a:pPr algn="ctr">
@@ -27434,7 +27131,6 @@
           <a:lstStyle/>
           <a:p>
             <a:pPr algn="ctr"/>
-            <a:endParaRPr/>
           </a:p>
         </p:txBody>
       </p:sp>
@@ -27564,7 +27260,6 @@
           <a:lstStyle/>
           <a:p>
             <a:pPr algn="ctr"/>
-            <a:endParaRPr/>
           </a:p>
         </p:txBody>
       </p:sp>
@@ -27604,7 +27299,7 @@
           </a:fontRef>
         </p:style>
         <p:txBody>
-          <a:bodyPr wrap="none" rtlCol="0" anchor="ctr"/>
+          <a:bodyPr rtlCol="0" anchor="ctr" wrap="none"/>
           <a:lstStyle/>
           <a:p>
             <a:pPr algn="ctr">
@@ -27753,7 +27448,6 @@
           <a:lstStyle/>
           <a:p>
             <a:pPr algn="ctr"/>
-            <a:endParaRPr/>
           </a:p>
         </p:txBody>
       </p:sp>
@@ -27883,7 +27577,6 @@
           <a:lstStyle/>
           <a:p>
             <a:pPr algn="ctr"/>
-            <a:endParaRPr/>
           </a:p>
         </p:txBody>
       </p:sp>
@@ -27923,7 +27616,7 @@
           </a:fontRef>
         </p:style>
         <p:txBody>
-          <a:bodyPr wrap="none" rtlCol="0" anchor="ctr"/>
+          <a:bodyPr rtlCol="0" anchor="ctr" wrap="none"/>
           <a:lstStyle/>
           <a:p>
             <a:pPr algn="ctr">
@@ -28025,7 +27718,7 @@
               </a:defRPr>
             </a:pPr>
             <a:r>
-              <a:t>Autonomous remediation on critical infrastructure</a:t>
+              <a:t>Applying recommended remediations on critical infrastructure</a:t>
             </a:r>
           </a:p>
         </p:txBody>
@@ -28072,7 +27765,6 @@
           <a:lstStyle/>
           <a:p>
             <a:pPr algn="ctr"/>
-            <a:endParaRPr/>
           </a:p>
         </p:txBody>
       </p:sp>
@@ -28155,7 +27847,7 @@
               </a:defRPr>
             </a:pPr>
             <a:r>
-              <a:t>Human-in-the-loop override + full audit trails</a:t>
+              <a:t>Human-in-the-loop approval + full audit trails</a:t>
             </a:r>
           </a:p>
         </p:txBody>
@@ -28202,7 +27894,6 @@
           <a:lstStyle/>
           <a:p>
             <a:pPr algn="ctr"/>
-            <a:endParaRPr/>
           </a:p>
         </p:txBody>
       </p:sp>
@@ -28242,7 +27933,7 @@
           </a:fontRef>
         </p:style>
         <p:txBody>
-          <a:bodyPr wrap="none" rtlCol="0" anchor="ctr"/>
+          <a:bodyPr rtlCol="0" anchor="ctr" wrap="none"/>
           <a:lstStyle/>
           <a:p>
             <a:pPr algn="ctr">
@@ -28391,7 +28082,6 @@
           <a:lstStyle/>
           <a:p>
             <a:pPr algn="ctr"/>
-            <a:endParaRPr/>
           </a:p>
         </p:txBody>
       </p:sp>
@@ -28521,7 +28211,6 @@
           <a:lstStyle/>
           <a:p>
             <a:pPr algn="ctr"/>
-            <a:endParaRPr/>
           </a:p>
         </p:txBody>
       </p:sp>
@@ -28561,7 +28250,7 @@
           </a:fontRef>
         </p:style>
         <p:txBody>
-          <a:bodyPr wrap="none" rtlCol="0" anchor="ctr"/>
+          <a:bodyPr rtlCol="0" anchor="ctr" wrap="none"/>
           <a:lstStyle/>
           <a:p>
             <a:pPr algn="ctr">
@@ -28710,7 +28399,6 @@
           <a:lstStyle/>
           <a:p>
             <a:pPr algn="ctr"/>
-            <a:endParaRPr/>
           </a:p>
         </p:txBody>
       </p:sp>
@@ -28840,7 +28528,6 @@
           <a:lstStyle/>
           <a:p>
             <a:pPr algn="ctr"/>
-            <a:endParaRPr/>
           </a:p>
         </p:txBody>
       </p:sp>
@@ -28880,7 +28567,7 @@
           </a:fontRef>
         </p:style>
         <p:txBody>
-          <a:bodyPr wrap="none" rtlCol="0" anchor="ctr"/>
+          <a:bodyPr rtlCol="0" anchor="ctr" wrap="none"/>
           <a:lstStyle/>
           <a:p>
             <a:pPr algn="ctr">
@@ -29029,7 +28716,6 @@
           <a:lstStyle/>
           <a:p>
             <a:pPr algn="ctr"/>
-            <a:endParaRPr/>
           </a:p>
         </p:txBody>
       </p:sp>
@@ -29159,7 +28845,6 @@
           <a:lstStyle/>
           <a:p>
             <a:pPr algn="ctr"/>
-            <a:endParaRPr/>
           </a:p>
         </p:txBody>
       </p:sp>
@@ -29199,7 +28884,7 @@
           </a:fontRef>
         </p:style>
         <p:txBody>
-          <a:bodyPr wrap="none" rtlCol="0" anchor="ctr"/>
+          <a:bodyPr rtlCol="0" anchor="ctr" wrap="none"/>
           <a:lstStyle/>
           <a:p>
             <a:pPr algn="ctr">
@@ -29348,7 +29033,6 @@
           <a:lstStyle/>
           <a:p>
             <a:pPr algn="ctr"/>
-            <a:endParaRPr/>
           </a:p>
         </p:txBody>
       </p:sp>

</xml_diff>